<commit_message>
Sunum: isim eklendi (pptx) + slayt-basi konusma scripti eklendi
- Akilli_Otopark_Sunum.pptx guncellendi (sunucu Mehmet Ali Topkara eklendi).
- SUNUM_KONUSMA_SCRIPTI.md: her slayt icin ~30-40 sn konusma metni, terim
  aciklamalari (MQTT/A*/LLM/maliyet fonksiyonu...), terimler sozlugu ve olasi
  sorular bolumu.

Co-Authored-By: Claude Opus 4.8 <noreply@anthropic.com>
</commit_message>
<xml_diff>
--- a/Akilli_Otopark_Sunum.pptx
+++ b/Akilli_Otopark_Sunum.pptx
@@ -5,18 +5,18 @@
     <p:sldMasterId id="2147483648" r:id="rId1"/>
   </p:sldMasterIdLst>
   <p:sldIdLst>
-    <p:sldId id="256" r:id="rId7"/>
-    <p:sldId id="257" r:id="rId8"/>
-    <p:sldId id="258" r:id="rId9"/>
-    <p:sldId id="259" r:id="rId10"/>
-    <p:sldId id="260" r:id="rId11"/>
-    <p:sldId id="261" r:id="rId12"/>
-    <p:sldId id="262" r:id="rId13"/>
-    <p:sldId id="263" r:id="rId14"/>
-    <p:sldId id="264" r:id="rId15"/>
-    <p:sldId id="265" r:id="rId16"/>
+    <p:sldId id="256" r:id="rId2"/>
+    <p:sldId id="257" r:id="rId3"/>
+    <p:sldId id="258" r:id="rId4"/>
+    <p:sldId id="259" r:id="rId5"/>
+    <p:sldId id="260" r:id="rId6"/>
+    <p:sldId id="261" r:id="rId7"/>
+    <p:sldId id="262" r:id="rId8"/>
+    <p:sldId id="263" r:id="rId9"/>
+    <p:sldId id="264" r:id="rId10"/>
+    <p:sldId id="265" r:id="rId11"/>
   </p:sldIdLst>
-  <p:sldSz cx="12191695" cy="6858000" type="screen4x3"/>
+  <p:sldSz cx="12192000" cy="6858000"/>
   <p:notesSz cx="6858000" cy="9144000"/>
   <p:defaultTextStyle>
     <a:defPPr>
@@ -113,6 +113,22 @@
       </a:defRPr>
     </a:lvl9pPr>
   </p:defaultTextStyle>
+  <p:extLst>
+    <p:ext uri="{EFAFB233-063F-42B5-8137-9DF3F51BA10A}">
+      <p15:sldGuideLst xmlns:p15="http://schemas.microsoft.com/office/powerpoint/2012/main">
+        <p15:guide id="1" orient="horz" pos="2160">
+          <p15:clr>
+            <a:srgbClr val="A4A3A4"/>
+          </p15:clr>
+        </p15:guide>
+        <p15:guide id="2" pos="2880">
+          <p15:clr>
+            <a:srgbClr val="A4A3A4"/>
+          </p15:clr>
+        </p15:guide>
+      </p15:sldGuideLst>
+    </p:ext>
+  </p:extLst>
 </p:presentation>
 </file>
 
@@ -154,10 +170,9 @@
           <a:lstStyle/>
           <a:p>
             <a:r>
-              <a:rPr lang="en-US" smtClean="0"/>
+              <a:rPr lang="en-US"/>
               <a:t>Click to edit Master title style</a:t>
             </a:r>
-            <a:endParaRPr lang="en-US"/>
           </a:p>
         </p:txBody>
       </p:sp>
@@ -273,10 +288,9 @@
           </a:lstStyle>
           <a:p>
             <a:r>
-              <a:rPr lang="en-US" smtClean="0"/>
+              <a:rPr lang="en-US"/>
               <a:t>Click to edit Master subtitle style</a:t>
             </a:r>
-            <a:endParaRPr lang="en-US"/>
           </a:p>
         </p:txBody>
       </p:sp>
@@ -297,7 +311,7 @@
           <a:p>
             <a:fld id="{5BCAD085-E8A6-8845-BD4E-CB4CCA059FC4}" type="datetimeFigureOut">
               <a:rPr lang="en-US" smtClean="0"/>
-              <a:t>1/27/13</a:t>
+              <a:t>6/3/2026</a:t>
             </a:fld>
             <a:endParaRPr lang="en-US"/>
           </a:p>
@@ -391,10 +405,9 @@
           <a:lstStyle/>
           <a:p>
             <a:r>
-              <a:rPr lang="en-US" smtClean="0"/>
+              <a:rPr lang="en-US"/>
               <a:t>Click to edit Master title style</a:t>
             </a:r>
-            <a:endParaRPr lang="en-US"/>
           </a:p>
         </p:txBody>
       </p:sp>
@@ -415,38 +428,37 @@
           <a:p>
             <a:pPr lvl="0"/>
             <a:r>
-              <a:rPr lang="en-US" smtClean="0"/>
+              <a:rPr lang="en-US"/>
               <a:t>Click to edit Master text styles</a:t>
             </a:r>
           </a:p>
           <a:p>
             <a:pPr lvl="1"/>
             <a:r>
-              <a:rPr lang="en-US" smtClean="0"/>
+              <a:rPr lang="en-US"/>
               <a:t>Second level</a:t>
             </a:r>
           </a:p>
           <a:p>
             <a:pPr lvl="2"/>
             <a:r>
-              <a:rPr lang="en-US" smtClean="0"/>
+              <a:rPr lang="en-US"/>
               <a:t>Third level</a:t>
             </a:r>
           </a:p>
           <a:p>
             <a:pPr lvl="3"/>
             <a:r>
-              <a:rPr lang="en-US" smtClean="0"/>
+              <a:rPr lang="en-US"/>
               <a:t>Fourth level</a:t>
             </a:r>
           </a:p>
           <a:p>
             <a:pPr lvl="4"/>
             <a:r>
-              <a:rPr lang="en-US" smtClean="0"/>
+              <a:rPr lang="en-US"/>
               <a:t>Fifth level</a:t>
             </a:r>
-            <a:endParaRPr lang="en-US"/>
           </a:p>
         </p:txBody>
       </p:sp>
@@ -467,7 +479,7 @@
           <a:p>
             <a:fld id="{5BCAD085-E8A6-8845-BD4E-CB4CCA059FC4}" type="datetimeFigureOut">
               <a:rPr lang="en-US" smtClean="0"/>
-              <a:t>1/27/13</a:t>
+              <a:t>6/3/2026</a:t>
             </a:fld>
             <a:endParaRPr lang="en-US"/>
           </a:p>
@@ -566,10 +578,9 @@
           <a:lstStyle/>
           <a:p>
             <a:r>
-              <a:rPr lang="en-US" smtClean="0"/>
+              <a:rPr lang="en-US"/>
               <a:t>Click to edit Master title style</a:t>
             </a:r>
-            <a:endParaRPr lang="en-US"/>
           </a:p>
         </p:txBody>
       </p:sp>
@@ -595,38 +606,37 @@
           <a:p>
             <a:pPr lvl="0"/>
             <a:r>
-              <a:rPr lang="en-US" smtClean="0"/>
+              <a:rPr lang="en-US"/>
               <a:t>Click to edit Master text styles</a:t>
             </a:r>
           </a:p>
           <a:p>
             <a:pPr lvl="1"/>
             <a:r>
-              <a:rPr lang="en-US" smtClean="0"/>
+              <a:rPr lang="en-US"/>
               <a:t>Second level</a:t>
             </a:r>
           </a:p>
           <a:p>
             <a:pPr lvl="2"/>
             <a:r>
-              <a:rPr lang="en-US" smtClean="0"/>
+              <a:rPr lang="en-US"/>
               <a:t>Third level</a:t>
             </a:r>
           </a:p>
           <a:p>
             <a:pPr lvl="3"/>
             <a:r>
-              <a:rPr lang="en-US" smtClean="0"/>
+              <a:rPr lang="en-US"/>
               <a:t>Fourth level</a:t>
             </a:r>
           </a:p>
           <a:p>
             <a:pPr lvl="4"/>
             <a:r>
-              <a:rPr lang="en-US" smtClean="0"/>
+              <a:rPr lang="en-US"/>
               <a:t>Fifth level</a:t>
             </a:r>
-            <a:endParaRPr lang="en-US"/>
           </a:p>
         </p:txBody>
       </p:sp>
@@ -647,7 +657,7 @@
           <a:p>
             <a:fld id="{5BCAD085-E8A6-8845-BD4E-CB4CCA059FC4}" type="datetimeFigureOut">
               <a:rPr lang="en-US" smtClean="0"/>
-              <a:t>1/27/13</a:t>
+              <a:t>6/3/2026</a:t>
             </a:fld>
             <a:endParaRPr lang="en-US"/>
           </a:p>
@@ -741,10 +751,9 @@
           <a:lstStyle/>
           <a:p>
             <a:r>
-              <a:rPr lang="en-US" smtClean="0"/>
+              <a:rPr lang="en-US"/>
               <a:t>Click to edit Master title style</a:t>
             </a:r>
-            <a:endParaRPr lang="en-US"/>
           </a:p>
         </p:txBody>
       </p:sp>
@@ -765,38 +774,37 @@
           <a:p>
             <a:pPr lvl="0"/>
             <a:r>
-              <a:rPr lang="en-US" smtClean="0"/>
+              <a:rPr lang="en-US"/>
               <a:t>Click to edit Master text styles</a:t>
             </a:r>
           </a:p>
           <a:p>
             <a:pPr lvl="1"/>
             <a:r>
-              <a:rPr lang="en-US" smtClean="0"/>
+              <a:rPr lang="en-US"/>
               <a:t>Second level</a:t>
             </a:r>
           </a:p>
           <a:p>
             <a:pPr lvl="2"/>
             <a:r>
-              <a:rPr lang="en-US" smtClean="0"/>
+              <a:rPr lang="en-US"/>
               <a:t>Third level</a:t>
             </a:r>
           </a:p>
           <a:p>
             <a:pPr lvl="3"/>
             <a:r>
-              <a:rPr lang="en-US" smtClean="0"/>
+              <a:rPr lang="en-US"/>
               <a:t>Fourth level</a:t>
             </a:r>
           </a:p>
           <a:p>
             <a:pPr lvl="4"/>
             <a:r>
-              <a:rPr lang="en-US" smtClean="0"/>
+              <a:rPr lang="en-US"/>
               <a:t>Fifth level</a:t>
             </a:r>
-            <a:endParaRPr lang="en-US"/>
           </a:p>
         </p:txBody>
       </p:sp>
@@ -817,7 +825,7 @@
           <a:p>
             <a:fld id="{5BCAD085-E8A6-8845-BD4E-CB4CCA059FC4}" type="datetimeFigureOut">
               <a:rPr lang="en-US" smtClean="0"/>
-              <a:t>1/27/13</a:t>
+              <a:t>6/3/2026</a:t>
             </a:fld>
             <a:endParaRPr lang="en-US"/>
           </a:p>
@@ -920,10 +928,9 @@
           </a:lstStyle>
           <a:p>
             <a:r>
-              <a:rPr lang="en-US" smtClean="0"/>
+              <a:rPr lang="en-US"/>
               <a:t>Click to edit Master title style</a:t>
             </a:r>
-            <a:endParaRPr lang="en-US"/>
           </a:p>
         </p:txBody>
       </p:sp>
@@ -1040,7 +1047,7 @@
           <a:p>
             <a:pPr lvl="0"/>
             <a:r>
-              <a:rPr lang="en-US" smtClean="0"/>
+              <a:rPr lang="en-US"/>
               <a:t>Click to edit Master text styles</a:t>
             </a:r>
           </a:p>
@@ -1063,7 +1070,7 @@
           <a:p>
             <a:fld id="{5BCAD085-E8A6-8845-BD4E-CB4CCA059FC4}" type="datetimeFigureOut">
               <a:rPr lang="en-US" smtClean="0"/>
-              <a:t>1/27/13</a:t>
+              <a:t>6/3/2026</a:t>
             </a:fld>
             <a:endParaRPr lang="en-US"/>
           </a:p>
@@ -1157,10 +1164,9 @@
           <a:lstStyle/>
           <a:p>
             <a:r>
-              <a:rPr lang="en-US" smtClean="0"/>
+              <a:rPr lang="en-US"/>
               <a:t>Click to edit Master title style</a:t>
             </a:r>
-            <a:endParaRPr lang="en-US"/>
           </a:p>
         </p:txBody>
       </p:sp>
@@ -1214,38 +1220,37 @@
           <a:p>
             <a:pPr lvl="0"/>
             <a:r>
-              <a:rPr lang="en-US" smtClean="0"/>
+              <a:rPr lang="en-US"/>
               <a:t>Click to edit Master text styles</a:t>
             </a:r>
           </a:p>
           <a:p>
             <a:pPr lvl="1"/>
             <a:r>
-              <a:rPr lang="en-US" smtClean="0"/>
+              <a:rPr lang="en-US"/>
               <a:t>Second level</a:t>
             </a:r>
           </a:p>
           <a:p>
             <a:pPr lvl="2"/>
             <a:r>
-              <a:rPr lang="en-US" smtClean="0"/>
+              <a:rPr lang="en-US"/>
               <a:t>Third level</a:t>
             </a:r>
           </a:p>
           <a:p>
             <a:pPr lvl="3"/>
             <a:r>
-              <a:rPr lang="en-US" smtClean="0"/>
+              <a:rPr lang="en-US"/>
               <a:t>Fourth level</a:t>
             </a:r>
           </a:p>
           <a:p>
             <a:pPr lvl="4"/>
             <a:r>
-              <a:rPr lang="en-US" smtClean="0"/>
+              <a:rPr lang="en-US"/>
               <a:t>Fifth level</a:t>
             </a:r>
-            <a:endParaRPr lang="en-US"/>
           </a:p>
         </p:txBody>
       </p:sp>
@@ -1299,38 +1304,37 @@
           <a:p>
             <a:pPr lvl="0"/>
             <a:r>
-              <a:rPr lang="en-US" smtClean="0"/>
+              <a:rPr lang="en-US"/>
               <a:t>Click to edit Master text styles</a:t>
             </a:r>
           </a:p>
           <a:p>
             <a:pPr lvl="1"/>
             <a:r>
-              <a:rPr lang="en-US" smtClean="0"/>
+              <a:rPr lang="en-US"/>
               <a:t>Second level</a:t>
             </a:r>
           </a:p>
           <a:p>
             <a:pPr lvl="2"/>
             <a:r>
-              <a:rPr lang="en-US" smtClean="0"/>
+              <a:rPr lang="en-US"/>
               <a:t>Third level</a:t>
             </a:r>
           </a:p>
           <a:p>
             <a:pPr lvl="3"/>
             <a:r>
-              <a:rPr lang="en-US" smtClean="0"/>
+              <a:rPr lang="en-US"/>
               <a:t>Fourth level</a:t>
             </a:r>
           </a:p>
           <a:p>
             <a:pPr lvl="4"/>
             <a:r>
-              <a:rPr lang="en-US" smtClean="0"/>
+              <a:rPr lang="en-US"/>
               <a:t>Fifth level</a:t>
             </a:r>
-            <a:endParaRPr lang="en-US"/>
           </a:p>
         </p:txBody>
       </p:sp>
@@ -1351,7 +1355,7 @@
           <a:p>
             <a:fld id="{5BCAD085-E8A6-8845-BD4E-CB4CCA059FC4}" type="datetimeFigureOut">
               <a:rPr lang="en-US" smtClean="0"/>
-              <a:t>1/27/13</a:t>
+              <a:t>6/3/2026</a:t>
             </a:fld>
             <a:endParaRPr lang="en-US"/>
           </a:p>
@@ -1449,10 +1453,9 @@
           </a:lstStyle>
           <a:p>
             <a:r>
-              <a:rPr lang="en-US" smtClean="0"/>
+              <a:rPr lang="en-US"/>
               <a:t>Click to edit Master title style</a:t>
             </a:r>
-            <a:endParaRPr lang="en-US"/>
           </a:p>
         </p:txBody>
       </p:sp>
@@ -1515,7 +1518,7 @@
           <a:p>
             <a:pPr lvl="0"/>
             <a:r>
-              <a:rPr lang="en-US" smtClean="0"/>
+              <a:rPr lang="en-US"/>
               <a:t>Click to edit Master text styles</a:t>
             </a:r>
           </a:p>
@@ -1571,38 +1574,37 @@
           <a:p>
             <a:pPr lvl="0"/>
             <a:r>
-              <a:rPr lang="en-US" smtClean="0"/>
+              <a:rPr lang="en-US"/>
               <a:t>Click to edit Master text styles</a:t>
             </a:r>
           </a:p>
           <a:p>
             <a:pPr lvl="1"/>
             <a:r>
-              <a:rPr lang="en-US" smtClean="0"/>
+              <a:rPr lang="en-US"/>
               <a:t>Second level</a:t>
             </a:r>
           </a:p>
           <a:p>
             <a:pPr lvl="2"/>
             <a:r>
-              <a:rPr lang="en-US" smtClean="0"/>
+              <a:rPr lang="en-US"/>
               <a:t>Third level</a:t>
             </a:r>
           </a:p>
           <a:p>
             <a:pPr lvl="3"/>
             <a:r>
-              <a:rPr lang="en-US" smtClean="0"/>
+              <a:rPr lang="en-US"/>
               <a:t>Fourth level</a:t>
             </a:r>
           </a:p>
           <a:p>
             <a:pPr lvl="4"/>
             <a:r>
-              <a:rPr lang="en-US" smtClean="0"/>
+              <a:rPr lang="en-US"/>
               <a:t>Fifth level</a:t>
             </a:r>
-            <a:endParaRPr lang="en-US"/>
           </a:p>
         </p:txBody>
       </p:sp>
@@ -1665,7 +1667,7 @@
           <a:p>
             <a:pPr lvl="0"/>
             <a:r>
-              <a:rPr lang="en-US" smtClean="0"/>
+              <a:rPr lang="en-US"/>
               <a:t>Click to edit Master text styles</a:t>
             </a:r>
           </a:p>
@@ -1721,38 +1723,37 @@
           <a:p>
             <a:pPr lvl="0"/>
             <a:r>
-              <a:rPr lang="en-US" smtClean="0"/>
+              <a:rPr lang="en-US"/>
               <a:t>Click to edit Master text styles</a:t>
             </a:r>
           </a:p>
           <a:p>
             <a:pPr lvl="1"/>
             <a:r>
-              <a:rPr lang="en-US" smtClean="0"/>
+              <a:rPr lang="en-US"/>
               <a:t>Second level</a:t>
             </a:r>
           </a:p>
           <a:p>
             <a:pPr lvl="2"/>
             <a:r>
-              <a:rPr lang="en-US" smtClean="0"/>
+              <a:rPr lang="en-US"/>
               <a:t>Third level</a:t>
             </a:r>
           </a:p>
           <a:p>
             <a:pPr lvl="3"/>
             <a:r>
-              <a:rPr lang="en-US" smtClean="0"/>
+              <a:rPr lang="en-US"/>
               <a:t>Fourth level</a:t>
             </a:r>
           </a:p>
           <a:p>
             <a:pPr lvl="4"/>
             <a:r>
-              <a:rPr lang="en-US" smtClean="0"/>
+              <a:rPr lang="en-US"/>
               <a:t>Fifth level</a:t>
             </a:r>
-            <a:endParaRPr lang="en-US"/>
           </a:p>
         </p:txBody>
       </p:sp>
@@ -1773,7 +1774,7 @@
           <a:p>
             <a:fld id="{5BCAD085-E8A6-8845-BD4E-CB4CCA059FC4}" type="datetimeFigureOut">
               <a:rPr lang="en-US" smtClean="0"/>
-              <a:t>1/27/13</a:t>
+              <a:t>6/3/2026</a:t>
             </a:fld>
             <a:endParaRPr lang="en-US"/>
           </a:p>
@@ -1867,10 +1868,9 @@
           <a:lstStyle/>
           <a:p>
             <a:r>
-              <a:rPr lang="en-US" smtClean="0"/>
+              <a:rPr lang="en-US"/>
               <a:t>Click to edit Master title style</a:t>
             </a:r>
-            <a:endParaRPr lang="en-US"/>
           </a:p>
         </p:txBody>
       </p:sp>
@@ -1891,7 +1891,7 @@
           <a:p>
             <a:fld id="{5BCAD085-E8A6-8845-BD4E-CB4CCA059FC4}" type="datetimeFigureOut">
               <a:rPr lang="en-US" smtClean="0"/>
-              <a:t>1/27/13</a:t>
+              <a:t>6/3/2026</a:t>
             </a:fld>
             <a:endParaRPr lang="en-US"/>
           </a:p>
@@ -1986,7 +1986,7 @@
           <a:p>
             <a:fld id="{5BCAD085-E8A6-8845-BD4E-CB4CCA059FC4}" type="datetimeFigureOut">
               <a:rPr lang="en-US" smtClean="0"/>
-              <a:t>1/27/13</a:t>
+              <a:t>6/3/2026</a:t>
             </a:fld>
             <a:endParaRPr lang="en-US"/>
           </a:p>
@@ -2089,10 +2089,9 @@
           </a:lstStyle>
           <a:p>
             <a:r>
-              <a:rPr lang="en-US" smtClean="0"/>
+              <a:rPr lang="en-US"/>
               <a:t>Click to edit Master title style</a:t>
             </a:r>
-            <a:endParaRPr lang="en-US"/>
           </a:p>
         </p:txBody>
       </p:sp>
@@ -2146,38 +2145,37 @@
           <a:p>
             <a:pPr lvl="0"/>
             <a:r>
-              <a:rPr lang="en-US" smtClean="0"/>
+              <a:rPr lang="en-US"/>
               <a:t>Click to edit Master text styles</a:t>
             </a:r>
           </a:p>
           <a:p>
             <a:pPr lvl="1"/>
             <a:r>
-              <a:rPr lang="en-US" smtClean="0"/>
+              <a:rPr lang="en-US"/>
               <a:t>Second level</a:t>
             </a:r>
           </a:p>
           <a:p>
             <a:pPr lvl="2"/>
             <a:r>
-              <a:rPr lang="en-US" smtClean="0"/>
+              <a:rPr lang="en-US"/>
               <a:t>Third level</a:t>
             </a:r>
           </a:p>
           <a:p>
             <a:pPr lvl="3"/>
             <a:r>
-              <a:rPr lang="en-US" smtClean="0"/>
+              <a:rPr lang="en-US"/>
               <a:t>Fourth level</a:t>
             </a:r>
           </a:p>
           <a:p>
             <a:pPr lvl="4"/>
             <a:r>
-              <a:rPr lang="en-US" smtClean="0"/>
+              <a:rPr lang="en-US"/>
               <a:t>Fifth level</a:t>
             </a:r>
-            <a:endParaRPr lang="en-US"/>
           </a:p>
         </p:txBody>
       </p:sp>
@@ -2240,7 +2238,7 @@
           <a:p>
             <a:pPr lvl="0"/>
             <a:r>
-              <a:rPr lang="en-US" smtClean="0"/>
+              <a:rPr lang="en-US"/>
               <a:t>Click to edit Master text styles</a:t>
             </a:r>
           </a:p>
@@ -2263,7 +2261,7 @@
           <a:p>
             <a:fld id="{5BCAD085-E8A6-8845-BD4E-CB4CCA059FC4}" type="datetimeFigureOut">
               <a:rPr lang="en-US" smtClean="0"/>
-              <a:t>1/27/13</a:t>
+              <a:t>6/3/2026</a:t>
             </a:fld>
             <a:endParaRPr lang="en-US"/>
           </a:p>
@@ -2366,10 +2364,9 @@
           </a:lstStyle>
           <a:p>
             <a:r>
-              <a:rPr lang="en-US" smtClean="0"/>
+              <a:rPr lang="en-US"/>
               <a:t>Click to edit Master title style</a:t>
             </a:r>
-            <a:endParaRPr lang="en-US"/>
           </a:p>
         </p:txBody>
       </p:sp>
@@ -2493,7 +2490,7 @@
           <a:p>
             <a:pPr lvl="0"/>
             <a:r>
-              <a:rPr lang="en-US" smtClean="0"/>
+              <a:rPr lang="en-US"/>
               <a:t>Click to edit Master text styles</a:t>
             </a:r>
           </a:p>
@@ -2516,7 +2513,7 @@
           <a:p>
             <a:fld id="{5BCAD085-E8A6-8845-BD4E-CB4CCA059FC4}" type="datetimeFigureOut">
               <a:rPr lang="en-US" smtClean="0"/>
-              <a:t>1/27/13</a:t>
+              <a:t>6/3/2026</a:t>
             </a:fld>
             <a:endParaRPr lang="en-US"/>
           </a:p>
@@ -2625,10 +2622,9 @@
           <a:lstStyle/>
           <a:p>
             <a:r>
-              <a:rPr lang="en-US" smtClean="0"/>
+              <a:rPr lang="en-US"/>
               <a:t>Click to edit Master title style</a:t>
             </a:r>
-            <a:endParaRPr lang="en-US"/>
           </a:p>
         </p:txBody>
       </p:sp>
@@ -2659,38 +2655,37 @@
           <a:p>
             <a:pPr lvl="0"/>
             <a:r>
-              <a:rPr lang="en-US" smtClean="0"/>
+              <a:rPr lang="en-US"/>
               <a:t>Click to edit Master text styles</a:t>
             </a:r>
           </a:p>
           <a:p>
             <a:pPr lvl="1"/>
             <a:r>
-              <a:rPr lang="en-US" smtClean="0"/>
+              <a:rPr lang="en-US"/>
               <a:t>Second level</a:t>
             </a:r>
           </a:p>
           <a:p>
             <a:pPr lvl="2"/>
             <a:r>
-              <a:rPr lang="en-US" smtClean="0"/>
+              <a:rPr lang="en-US"/>
               <a:t>Third level</a:t>
             </a:r>
           </a:p>
           <a:p>
             <a:pPr lvl="3"/>
             <a:r>
-              <a:rPr lang="en-US" smtClean="0"/>
+              <a:rPr lang="en-US"/>
               <a:t>Fourth level</a:t>
             </a:r>
           </a:p>
           <a:p>
             <a:pPr lvl="4"/>
             <a:r>
-              <a:rPr lang="en-US" smtClean="0"/>
+              <a:rPr lang="en-US"/>
               <a:t>Fifth level</a:t>
             </a:r>
-            <a:endParaRPr lang="en-US"/>
           </a:p>
         </p:txBody>
       </p:sp>
@@ -2729,7 +2724,7 @@
           <a:p>
             <a:fld id="{5BCAD085-E8A6-8845-BD4E-CB4CCA059FC4}" type="datetimeFigureOut">
               <a:rPr lang="en-US" smtClean="0"/>
-              <a:t>1/27/13</a:t>
+              <a:t>6/3/2026</a:t>
             </a:fld>
             <a:endParaRPr lang="en-US"/>
           </a:p>
@@ -3088,7 +3083,7 @@
 </file>
 
 <file path=ppt/slides/slide1.xml><?xml version="1.0" encoding="utf-8"?>
-<p:sld xmlns:a="http://schemas.openxmlformats.org/drawingml/2006/main" xmlns:p="http://schemas.openxmlformats.org/presentationml/2006/main" xmlns:r="http://schemas.openxmlformats.org/officeDocument/2006/relationships">
+<p:sld xmlns:a="http://schemas.openxmlformats.org/drawingml/2006/main" xmlns:r="http://schemas.openxmlformats.org/officeDocument/2006/relationships" xmlns:p="http://schemas.openxmlformats.org/presentationml/2006/main">
   <p:cSld>
     <p:spTree>
       <p:nvGrpSpPr>
@@ -3096,7 +3091,14 @@
         <p:cNvGrpSpPr/>
         <p:nvPr/>
       </p:nvGrpSpPr>
-      <p:grpSpPr/>
+      <p:grpSpPr>
+        <a:xfrm>
+          <a:off x="0" y="0"/>
+          <a:ext cx="0" cy="0"/>
+          <a:chOff x="0" y="0"/>
+          <a:chExt cx="0" cy="0"/>
+        </a:xfrm>
+      </p:grpSpPr>
       <p:sp>
         <p:nvSpPr>
           <p:cNvPr id="2" name="Rectangle 1"/>
@@ -3138,6 +3140,7 @@
           <a:lstStyle/>
           <a:p>
             <a:pPr algn="ctr"/>
+            <a:endParaRPr/>
           </a:p>
         </p:txBody>
       </p:sp>
@@ -3182,6 +3185,7 @@
           <a:lstStyle/>
           <a:p>
             <a:pPr algn="ctr"/>
+            <a:endParaRPr/>
           </a:p>
         </p:txBody>
       </p:sp>
@@ -3226,6 +3230,7 @@
           <a:lstStyle/>
           <a:p>
             <a:pPr algn="ctr"/>
+            <a:endParaRPr/>
           </a:p>
         </p:txBody>
       </p:sp>
@@ -3270,6 +3275,7 @@
           <a:lstStyle/>
           <a:p>
             <a:pPr algn="ctr"/>
+            <a:endParaRPr/>
           </a:p>
         </p:txBody>
       </p:sp>
@@ -3290,7 +3296,7 @@
           <a:noFill/>
         </p:spPr>
         <p:txBody>
-          <a:bodyPr wrap="square" anchor="t" lIns="0" rIns="0" tIns="0" bIns="0">
+          <a:bodyPr wrap="square" lIns="0" tIns="0" rIns="0" bIns="0" anchor="t">
             <a:spAutoFit/>
           </a:bodyPr>
           <a:lstStyle/>
@@ -3332,7 +3338,7 @@
           <a:noFill/>
         </p:spPr>
         <p:txBody>
-          <a:bodyPr wrap="square" anchor="t" lIns="0" rIns="0" tIns="0" bIns="0">
+          <a:bodyPr wrap="square" lIns="0" tIns="0" rIns="0" bIns="0" anchor="t">
             <a:spAutoFit/>
           </a:bodyPr>
           <a:lstStyle/>
@@ -3385,7 +3391,7 @@
         <p:spPr>
           <a:xfrm>
             <a:off x="822960" y="4892040"/>
-            <a:ext cx="10607040" cy="1097280"/>
+            <a:ext cx="10607040" cy="574516"/>
           </a:xfrm>
           <a:prstGeom prst="rect">
             <a:avLst/>
@@ -3393,7 +3399,7 @@
           <a:noFill/>
         </p:spPr>
         <p:txBody>
-          <a:bodyPr wrap="square" anchor="t" lIns="0" rIns="0" tIns="0" bIns="0">
+          <a:bodyPr wrap="square" lIns="0" tIns="0" rIns="0" bIns="0" anchor="t">
             <a:spAutoFit/>
           </a:bodyPr>
           <a:lstStyle/>
@@ -3407,13 +3413,229 @@
               </a:spcAft>
             </a:pPr>
             <a:r>
-              <a:rPr sz="1500" b="0">
+              <a:rPr sz="1500" b="0" dirty="0">
                 <a:solidFill>
                   <a:srgbClr val="C9CED8"/>
                 </a:solidFill>
                 <a:latin typeface="Segoe UI"/>
               </a:rPr>
-              <a:t>Sürücü doğal dille konuşur → LLM anlar → algoritma en uygun yeri seçer → web’de canlı gösterilir.</a:t>
+              <a:t>Sürücü </a:t>
+            </a:r>
+            <a:r>
+              <a:rPr sz="1500" b="0" dirty="0" err="1">
+                <a:solidFill>
+                  <a:srgbClr val="C9CED8"/>
+                </a:solidFill>
+                <a:latin typeface="Segoe UI"/>
+              </a:rPr>
+              <a:t>doğal</a:t>
+            </a:r>
+            <a:r>
+              <a:rPr sz="1500" b="0" dirty="0">
+                <a:solidFill>
+                  <a:srgbClr val="C9CED8"/>
+                </a:solidFill>
+                <a:latin typeface="Segoe UI"/>
+              </a:rPr>
+              <a:t> </a:t>
+            </a:r>
+            <a:r>
+              <a:rPr sz="1500" b="0" dirty="0" err="1">
+                <a:solidFill>
+                  <a:srgbClr val="C9CED8"/>
+                </a:solidFill>
+                <a:latin typeface="Segoe UI"/>
+              </a:rPr>
+              <a:t>dille</a:t>
+            </a:r>
+            <a:r>
+              <a:rPr sz="1500" b="0" dirty="0">
+                <a:solidFill>
+                  <a:srgbClr val="C9CED8"/>
+                </a:solidFill>
+                <a:latin typeface="Segoe UI"/>
+              </a:rPr>
+              <a:t> </a:t>
+            </a:r>
+            <a:r>
+              <a:rPr sz="1500" b="0" dirty="0" err="1">
+                <a:solidFill>
+                  <a:srgbClr val="C9CED8"/>
+                </a:solidFill>
+                <a:latin typeface="Segoe UI"/>
+              </a:rPr>
+              <a:t>konuşur</a:t>
+            </a:r>
+            <a:r>
+              <a:rPr sz="1500" b="0" dirty="0">
+                <a:solidFill>
+                  <a:srgbClr val="C9CED8"/>
+                </a:solidFill>
+                <a:latin typeface="Segoe UI"/>
+              </a:rPr>
+              <a:t> → LLM </a:t>
+            </a:r>
+            <a:r>
+              <a:rPr sz="1500" b="0" dirty="0" err="1">
+                <a:solidFill>
+                  <a:srgbClr val="C9CED8"/>
+                </a:solidFill>
+                <a:latin typeface="Segoe UI"/>
+              </a:rPr>
+              <a:t>anlar</a:t>
+            </a:r>
+            <a:r>
+              <a:rPr sz="1500" b="0" dirty="0">
+                <a:solidFill>
+                  <a:srgbClr val="C9CED8"/>
+                </a:solidFill>
+                <a:latin typeface="Segoe UI"/>
+              </a:rPr>
+              <a:t> → </a:t>
+            </a:r>
+            <a:r>
+              <a:rPr sz="1500" b="0" dirty="0" err="1">
+                <a:solidFill>
+                  <a:srgbClr val="C9CED8"/>
+                </a:solidFill>
+                <a:latin typeface="Segoe UI"/>
+              </a:rPr>
+              <a:t>algoritma</a:t>
+            </a:r>
+            <a:r>
+              <a:rPr sz="1500" b="0" dirty="0">
+                <a:solidFill>
+                  <a:srgbClr val="C9CED8"/>
+                </a:solidFill>
+                <a:latin typeface="Segoe UI"/>
+              </a:rPr>
+              <a:t> </a:t>
+            </a:r>
+            <a:r>
+              <a:rPr sz="1500" b="0" dirty="0" err="1">
+                <a:solidFill>
+                  <a:srgbClr val="C9CED8"/>
+                </a:solidFill>
+                <a:latin typeface="Segoe UI"/>
+              </a:rPr>
+              <a:t>en</a:t>
+            </a:r>
+            <a:r>
+              <a:rPr sz="1500" b="0" dirty="0">
+                <a:solidFill>
+                  <a:srgbClr val="C9CED8"/>
+                </a:solidFill>
+                <a:latin typeface="Segoe UI"/>
+              </a:rPr>
+              <a:t> </a:t>
+            </a:r>
+            <a:r>
+              <a:rPr sz="1500" b="0" dirty="0" err="1">
+                <a:solidFill>
+                  <a:srgbClr val="C9CED8"/>
+                </a:solidFill>
+                <a:latin typeface="Segoe UI"/>
+              </a:rPr>
+              <a:t>uygun</a:t>
+            </a:r>
+            <a:r>
+              <a:rPr sz="1500" b="0" dirty="0">
+                <a:solidFill>
+                  <a:srgbClr val="C9CED8"/>
+                </a:solidFill>
+                <a:latin typeface="Segoe UI"/>
+              </a:rPr>
+              <a:t> </a:t>
+            </a:r>
+            <a:r>
+              <a:rPr sz="1500" b="0" dirty="0" err="1">
+                <a:solidFill>
+                  <a:srgbClr val="C9CED8"/>
+                </a:solidFill>
+                <a:latin typeface="Segoe UI"/>
+              </a:rPr>
+              <a:t>yeri</a:t>
+            </a:r>
+            <a:r>
+              <a:rPr sz="1500" b="0" dirty="0">
+                <a:solidFill>
+                  <a:srgbClr val="C9CED8"/>
+                </a:solidFill>
+                <a:latin typeface="Segoe UI"/>
+              </a:rPr>
+              <a:t> </a:t>
+            </a:r>
+            <a:r>
+              <a:rPr sz="1500" b="0" dirty="0" err="1">
+                <a:solidFill>
+                  <a:srgbClr val="C9CED8"/>
+                </a:solidFill>
+                <a:latin typeface="Segoe UI"/>
+              </a:rPr>
+              <a:t>seçer</a:t>
+            </a:r>
+            <a:r>
+              <a:rPr sz="1500" b="0" dirty="0">
+                <a:solidFill>
+                  <a:srgbClr val="C9CED8"/>
+                </a:solidFill>
+                <a:latin typeface="Segoe UI"/>
+              </a:rPr>
+              <a:t> → </a:t>
+            </a:r>
+            <a:r>
+              <a:rPr sz="1500" b="0" dirty="0" err="1">
+                <a:solidFill>
+                  <a:srgbClr val="C9CED8"/>
+                </a:solidFill>
+                <a:latin typeface="Segoe UI"/>
+              </a:rPr>
+              <a:t>web’de</a:t>
+            </a:r>
+            <a:r>
+              <a:rPr sz="1500" b="0" dirty="0">
+                <a:solidFill>
+                  <a:srgbClr val="C9CED8"/>
+                </a:solidFill>
+                <a:latin typeface="Segoe UI"/>
+              </a:rPr>
+              <a:t> </a:t>
+            </a:r>
+            <a:r>
+              <a:rPr sz="1500" b="0" dirty="0" err="1">
+                <a:solidFill>
+                  <a:srgbClr val="C9CED8"/>
+                </a:solidFill>
+                <a:latin typeface="Segoe UI"/>
+              </a:rPr>
+              <a:t>canlı</a:t>
+            </a:r>
+            <a:r>
+              <a:rPr sz="1500" b="0" dirty="0">
+                <a:solidFill>
+                  <a:srgbClr val="C9CED8"/>
+                </a:solidFill>
+                <a:latin typeface="Segoe UI"/>
+              </a:rPr>
+              <a:t> </a:t>
+            </a:r>
+            <a:r>
+              <a:rPr sz="1500" b="0" dirty="0" err="1">
+                <a:solidFill>
+                  <a:srgbClr val="C9CED8"/>
+                </a:solidFill>
+                <a:latin typeface="Segoe UI"/>
+              </a:rPr>
+              <a:t>gösterilir</a:t>
+            </a:r>
+            <a:r>
+              <a:rPr sz="1500" b="0" dirty="0">
+                <a:solidFill>
+                  <a:srgbClr val="C9CED8"/>
+                </a:solidFill>
+                <a:latin typeface="Segoe UI"/>
+              </a:rPr>
+              <a:t>.</a:t>
             </a:r>
           </a:p>
           <a:p>
@@ -3426,23 +3648,101 @@
               </a:spcAft>
             </a:pPr>
             <a:r>
-              <a:rPr sz="1400" b="1">
+              <a:rPr sz="1400" b="1" dirty="0" err="1">
                 <a:solidFill>
                   <a:srgbClr val="F3F5F8"/>
                 </a:solidFill>
                 <a:latin typeface="Segoe UI"/>
               </a:rPr>
-              <a:t>Hazırlayan:  Mehdi Sındağ   ·   [2. öğrenci adı]        </a:t>
-            </a:r>
-            <a:r>
-              <a:rPr sz="1400" b="0">
+              <a:t>Hazırlayan</a:t>
+            </a:r>
+            <a:r>
+              <a:rPr sz="1400" b="1" dirty="0">
+                <a:solidFill>
+                  <a:srgbClr val="F3F5F8"/>
+                </a:solidFill>
+                <a:latin typeface="Segoe UI"/>
+              </a:rPr>
+              <a:t>:  Mehdi </a:t>
+            </a:r>
+            <a:r>
+              <a:rPr sz="1400" b="1" dirty="0" err="1">
+                <a:solidFill>
+                  <a:srgbClr val="F3F5F8"/>
+                </a:solidFill>
+                <a:latin typeface="Segoe UI"/>
+              </a:rPr>
+              <a:t>Sındağ</a:t>
+            </a:r>
+            <a:r>
+              <a:rPr sz="1400" b="1" dirty="0">
+                <a:solidFill>
+                  <a:srgbClr val="F3F5F8"/>
+                </a:solidFill>
+                <a:latin typeface="Segoe UI"/>
+              </a:rPr>
+              <a:t>   ·   </a:t>
+            </a:r>
+            <a:r>
+              <a:rPr lang="tr-TR" sz="1400" b="1" dirty="0">
+                <a:solidFill>
+                  <a:srgbClr val="F3F5F8"/>
+                </a:solidFill>
+                <a:latin typeface="Segoe UI"/>
+              </a:rPr>
+              <a:t>Mehmet Ali Topkara  </a:t>
+            </a:r>
+            <a:r>
+              <a:rPr sz="1400" b="0" dirty="0" err="1">
                 <a:solidFill>
                   <a:srgbClr val="C9CED8"/>
                 </a:solidFill>
                 <a:latin typeface="Segoe UI"/>
               </a:rPr>
-              <a:t>Yapay Zeka ve Veri Mühendisliği</a:t>
-            </a:r>
+              <a:t>Yapay</a:t>
+            </a:r>
+            <a:r>
+              <a:rPr sz="1400" b="0" dirty="0">
+                <a:solidFill>
+                  <a:srgbClr val="C9CED8"/>
+                </a:solidFill>
+                <a:latin typeface="Segoe UI"/>
+              </a:rPr>
+              <a:t> Zeka </a:t>
+            </a:r>
+            <a:r>
+              <a:rPr sz="1400" b="0" dirty="0" err="1">
+                <a:solidFill>
+                  <a:srgbClr val="C9CED8"/>
+                </a:solidFill>
+                <a:latin typeface="Segoe UI"/>
+              </a:rPr>
+              <a:t>ve</a:t>
+            </a:r>
+            <a:r>
+              <a:rPr sz="1400" b="0" dirty="0">
+                <a:solidFill>
+                  <a:srgbClr val="C9CED8"/>
+                </a:solidFill>
+                <a:latin typeface="Segoe UI"/>
+              </a:rPr>
+              <a:t> Veri </a:t>
+            </a:r>
+            <a:r>
+              <a:rPr sz="1400" b="0" dirty="0" err="1">
+                <a:solidFill>
+                  <a:srgbClr val="C9CED8"/>
+                </a:solidFill>
+                <a:latin typeface="Segoe UI"/>
+              </a:rPr>
+              <a:t>Mühendisliği</a:t>
+            </a:r>
+            <a:endParaRPr sz="1400" b="0" dirty="0">
+              <a:solidFill>
+                <a:srgbClr val="C9CED8"/>
+              </a:solidFill>
+              <a:latin typeface="Segoe UI"/>
+            </a:endParaRPr>
           </a:p>
         </p:txBody>
       </p:sp>
@@ -3455,7 +3755,7 @@
 </file>
 
 <file path=ppt/slides/slide10.xml><?xml version="1.0" encoding="utf-8"?>
-<p:sld xmlns:a="http://schemas.openxmlformats.org/drawingml/2006/main" xmlns:p="http://schemas.openxmlformats.org/presentationml/2006/main" xmlns:r="http://schemas.openxmlformats.org/officeDocument/2006/relationships">
+<p:sld xmlns:a="http://schemas.openxmlformats.org/drawingml/2006/main" xmlns:r="http://schemas.openxmlformats.org/officeDocument/2006/relationships" xmlns:p="http://schemas.openxmlformats.org/presentationml/2006/main">
   <p:cSld>
     <p:spTree>
       <p:nvGrpSpPr>
@@ -3463,7 +3763,14 @@
         <p:cNvGrpSpPr/>
         <p:nvPr/>
       </p:nvGrpSpPr>
-      <p:grpSpPr/>
+      <p:grpSpPr>
+        <a:xfrm>
+          <a:off x="0" y="0"/>
+          <a:ext cx="0" cy="0"/>
+          <a:chOff x="0" y="0"/>
+          <a:chExt cx="0" cy="0"/>
+        </a:xfrm>
+      </p:grpSpPr>
       <p:sp>
         <p:nvSpPr>
           <p:cNvPr id="2" name="Rectangle 1"/>
@@ -3505,6 +3812,7 @@
           <a:lstStyle/>
           <a:p>
             <a:pPr algn="ctr"/>
+            <a:endParaRPr/>
           </a:p>
         </p:txBody>
       </p:sp>
@@ -3549,6 +3857,7 @@
           <a:lstStyle/>
           <a:p>
             <a:pPr algn="ctr"/>
+            <a:endParaRPr/>
           </a:p>
         </p:txBody>
       </p:sp>
@@ -3569,7 +3878,7 @@
           <a:noFill/>
         </p:spPr>
         <p:txBody>
-          <a:bodyPr wrap="square" anchor="t" lIns="0" rIns="0" tIns="0" bIns="0">
+          <a:bodyPr wrap="square" lIns="0" tIns="0" rIns="0" bIns="0" anchor="t">
             <a:spAutoFit/>
           </a:bodyPr>
           <a:lstStyle/>
@@ -3635,6 +3944,7 @@
           <a:lstStyle/>
           <a:p>
             <a:pPr algn="ctr"/>
+            <a:endParaRPr/>
           </a:p>
         </p:txBody>
       </p:sp>
@@ -3655,7 +3965,7 @@
           <a:noFill/>
         </p:spPr>
         <p:txBody>
-          <a:bodyPr wrap="square" anchor="t" lIns="0" rIns="0" tIns="0" bIns="0">
+          <a:bodyPr wrap="square" lIns="0" tIns="0" rIns="0" bIns="0" anchor="t">
             <a:spAutoFit/>
           </a:bodyPr>
           <a:lstStyle/>
@@ -3786,16 +4096,7 @@
                 </a:solidFill>
                 <a:latin typeface="Segoe UI"/>
               </a:rPr>
-              <a:t>▸  </a:t>
-            </a:r>
-            <a:r>
-              <a:rPr sz="1600" b="1">
-                <a:solidFill>
-                  <a:srgbClr val="6CD08A"/>
-                </a:solidFill>
-                <a:latin typeface="Segoe UI"/>
-              </a:rPr>
-              <a:t>Demo: </a:t>
+              <a:t>▸  Demo: </a:t>
             </a:r>
             <a:r>
               <a:rPr sz="1600" b="0">
@@ -3850,6 +4151,7 @@
           <a:lstStyle/>
           <a:p>
             <a:pPr algn="ctr"/>
+            <a:endParaRPr/>
           </a:p>
         </p:txBody>
       </p:sp>
@@ -3870,7 +4172,7 @@
           <a:noFill/>
         </p:spPr>
         <p:txBody>
-          <a:bodyPr wrap="square" anchor="ctr" lIns="0" rIns="0" tIns="0" bIns="0">
+          <a:bodyPr wrap="square" lIns="0" tIns="0" rIns="0" bIns="0" anchor="ctr">
             <a:spAutoFit/>
           </a:bodyPr>
           <a:lstStyle/>
@@ -3904,7 +4206,7 @@
 </file>
 
 <file path=ppt/slides/slide2.xml><?xml version="1.0" encoding="utf-8"?>
-<p:sld xmlns:a="http://schemas.openxmlformats.org/drawingml/2006/main" xmlns:p="http://schemas.openxmlformats.org/presentationml/2006/main" xmlns:r="http://schemas.openxmlformats.org/officeDocument/2006/relationships">
+<p:sld xmlns:a="http://schemas.openxmlformats.org/drawingml/2006/main" xmlns:r="http://schemas.openxmlformats.org/officeDocument/2006/relationships" xmlns:p="http://schemas.openxmlformats.org/presentationml/2006/main">
   <p:cSld>
     <p:spTree>
       <p:nvGrpSpPr>
@@ -3912,7 +4214,14 @@
         <p:cNvGrpSpPr/>
         <p:nvPr/>
       </p:nvGrpSpPr>
-      <p:grpSpPr/>
+      <p:grpSpPr>
+        <a:xfrm>
+          <a:off x="0" y="0"/>
+          <a:ext cx="0" cy="0"/>
+          <a:chOff x="0" y="0"/>
+          <a:chExt cx="0" cy="0"/>
+        </a:xfrm>
+      </p:grpSpPr>
       <p:sp>
         <p:nvSpPr>
           <p:cNvPr id="2" name="Rectangle 1"/>
@@ -3954,6 +4263,7 @@
           <a:lstStyle/>
           <a:p>
             <a:pPr algn="ctr"/>
+            <a:endParaRPr/>
           </a:p>
         </p:txBody>
       </p:sp>
@@ -3998,6 +4308,7 @@
           <a:lstStyle/>
           <a:p>
             <a:pPr algn="ctr"/>
+            <a:endParaRPr/>
           </a:p>
         </p:txBody>
       </p:sp>
@@ -4018,7 +4329,7 @@
           <a:noFill/>
         </p:spPr>
         <p:txBody>
-          <a:bodyPr wrap="square" anchor="t" lIns="0" rIns="0" tIns="0" bIns="0">
+          <a:bodyPr wrap="square" lIns="0" tIns="0" rIns="0" bIns="0" anchor="t">
             <a:spAutoFit/>
           </a:bodyPr>
           <a:lstStyle/>
@@ -4103,6 +4414,7 @@
           <a:lstStyle/>
           <a:p>
             <a:pPr algn="ctr"/>
+            <a:endParaRPr/>
           </a:p>
         </p:txBody>
       </p:sp>
@@ -4123,7 +4435,7 @@
           <a:noFill/>
         </p:spPr>
         <p:txBody>
-          <a:bodyPr wrap="square" anchor="t" lIns="0" rIns="0" tIns="0" bIns="0">
+          <a:bodyPr wrap="square" lIns="0" tIns="0" rIns="0" bIns="0" anchor="t">
             <a:spAutoFit/>
           </a:bodyPr>
           <a:lstStyle/>
@@ -4165,7 +4477,7 @@
           <a:noFill/>
         </p:spPr>
         <p:txBody>
-          <a:bodyPr wrap="square" anchor="t" lIns="0" rIns="0" tIns="0" bIns="0">
+          <a:bodyPr wrap="square" lIns="0" tIns="0" rIns="0" bIns="0" anchor="t">
             <a:spAutoFit/>
           </a:bodyPr>
           <a:lstStyle/>
@@ -4231,6 +4543,7 @@
           <a:lstStyle/>
           <a:p>
             <a:pPr algn="ctr"/>
+            <a:endParaRPr/>
           </a:p>
         </p:txBody>
       </p:sp>
@@ -4275,6 +4588,7 @@
           <a:lstStyle/>
           <a:p>
             <a:pPr algn="ctr"/>
+            <a:endParaRPr/>
           </a:p>
         </p:txBody>
       </p:sp>
@@ -4295,7 +4609,7 @@
           <a:noFill/>
         </p:spPr>
         <p:txBody>
-          <a:bodyPr wrap="square" anchor="t" lIns="0" rIns="0" tIns="0" bIns="0">
+          <a:bodyPr wrap="square" lIns="0" tIns="0" rIns="0" bIns="0" anchor="t">
             <a:spAutoFit/>
           </a:bodyPr>
           <a:lstStyle/>
@@ -4427,6 +4741,7 @@
           <a:lstStyle/>
           <a:p>
             <a:pPr algn="ctr"/>
+            <a:endParaRPr/>
           </a:p>
         </p:txBody>
       </p:sp>
@@ -4471,6 +4786,7 @@
           <a:lstStyle/>
           <a:p>
             <a:pPr algn="ctr"/>
+            <a:endParaRPr/>
           </a:p>
         </p:txBody>
       </p:sp>
@@ -4491,7 +4807,7 @@
           <a:noFill/>
         </p:spPr>
         <p:txBody>
-          <a:bodyPr wrap="square" anchor="t" lIns="0" rIns="0" tIns="0" bIns="0">
+          <a:bodyPr wrap="square" lIns="0" tIns="0" rIns="0" bIns="0" anchor="t">
             <a:spAutoFit/>
           </a:bodyPr>
           <a:lstStyle/>
@@ -4623,6 +4939,7 @@
           <a:lstStyle/>
           <a:p>
             <a:pPr algn="ctr"/>
+            <a:endParaRPr/>
           </a:p>
         </p:txBody>
       </p:sp>
@@ -4667,6 +4984,7 @@
           <a:lstStyle/>
           <a:p>
             <a:pPr algn="ctr"/>
+            <a:endParaRPr/>
           </a:p>
         </p:txBody>
       </p:sp>
@@ -4687,7 +5005,7 @@
           <a:noFill/>
         </p:spPr>
         <p:txBody>
-          <a:bodyPr wrap="square" anchor="t" lIns="0" rIns="0" tIns="0" bIns="0">
+          <a:bodyPr wrap="square" lIns="0" tIns="0" rIns="0" bIns="0" anchor="t">
             <a:spAutoFit/>
           </a:bodyPr>
           <a:lstStyle/>
@@ -4795,7 +5113,7 @@
           <a:noFill/>
         </p:spPr>
         <p:txBody>
-          <a:bodyPr wrap="square" anchor="t" lIns="0" rIns="0" tIns="0" bIns="0">
+          <a:bodyPr wrap="square" lIns="0" tIns="0" rIns="0" bIns="0" anchor="t">
             <a:spAutoFit/>
           </a:bodyPr>
           <a:lstStyle/>
@@ -4949,7 +5267,7 @@
 </file>
 
 <file path=ppt/slides/slide3.xml><?xml version="1.0" encoding="utf-8"?>
-<p:sld xmlns:a="http://schemas.openxmlformats.org/drawingml/2006/main" xmlns:p="http://schemas.openxmlformats.org/presentationml/2006/main" xmlns:r="http://schemas.openxmlformats.org/officeDocument/2006/relationships">
+<p:sld xmlns:a="http://schemas.openxmlformats.org/drawingml/2006/main" xmlns:r="http://schemas.openxmlformats.org/officeDocument/2006/relationships" xmlns:p="http://schemas.openxmlformats.org/presentationml/2006/main">
   <p:cSld>
     <p:spTree>
       <p:nvGrpSpPr>
@@ -4957,7 +5275,14 @@
         <p:cNvGrpSpPr/>
         <p:nvPr/>
       </p:nvGrpSpPr>
-      <p:grpSpPr/>
+      <p:grpSpPr>
+        <a:xfrm>
+          <a:off x="0" y="0"/>
+          <a:ext cx="0" cy="0"/>
+          <a:chOff x="0" y="0"/>
+          <a:chExt cx="0" cy="0"/>
+        </a:xfrm>
+      </p:grpSpPr>
       <p:sp>
         <p:nvSpPr>
           <p:cNvPr id="2" name="Rectangle 1"/>
@@ -4999,6 +5324,7 @@
           <a:lstStyle/>
           <a:p>
             <a:pPr algn="ctr"/>
+            <a:endParaRPr/>
           </a:p>
         </p:txBody>
       </p:sp>
@@ -5043,6 +5369,7 @@
           <a:lstStyle/>
           <a:p>
             <a:pPr algn="ctr"/>
+            <a:endParaRPr/>
           </a:p>
         </p:txBody>
       </p:sp>
@@ -5063,7 +5390,7 @@
           <a:noFill/>
         </p:spPr>
         <p:txBody>
-          <a:bodyPr wrap="square" anchor="t" lIns="0" rIns="0" tIns="0" bIns="0">
+          <a:bodyPr wrap="square" lIns="0" tIns="0" rIns="0" bIns="0" anchor="t">
             <a:spAutoFit/>
           </a:bodyPr>
           <a:lstStyle/>
@@ -5148,6 +5475,7 @@
           <a:lstStyle/>
           <a:p>
             <a:pPr algn="ctr"/>
+            <a:endParaRPr/>
           </a:p>
         </p:txBody>
       </p:sp>
@@ -5168,7 +5496,7 @@
           <a:noFill/>
         </p:spPr>
         <p:txBody>
-          <a:bodyPr wrap="square" anchor="t" lIns="0" rIns="0" tIns="0" bIns="0">
+          <a:bodyPr wrap="square" lIns="0" tIns="0" rIns="0" bIns="0" anchor="t">
             <a:spAutoFit/>
           </a:bodyPr>
           <a:lstStyle/>
@@ -5210,7 +5538,7 @@
           <a:noFill/>
         </p:spPr>
         <p:txBody>
-          <a:bodyPr wrap="square" anchor="t" lIns="0" rIns="0" tIns="0" bIns="0">
+          <a:bodyPr wrap="square" lIns="0" tIns="0" rIns="0" bIns="0" anchor="t">
             <a:spAutoFit/>
           </a:bodyPr>
           <a:lstStyle/>
@@ -5252,7 +5580,7 @@
           <a:noFill/>
         </p:spPr>
         <p:txBody>
-          <a:bodyPr wrap="square" anchor="t" lIns="0" rIns="0" tIns="0" bIns="0">
+          <a:bodyPr wrap="square" lIns="0" tIns="0" rIns="0" bIns="0" anchor="t">
             <a:spAutoFit/>
           </a:bodyPr>
           <a:lstStyle/>
@@ -5440,16 +5768,35 @@
                 </a:solidFill>
                 <a:latin typeface="Segoe UI"/>
               </a:rPr>
-              <a:t>▸  </a:t>
-            </a:r>
+              <a:t>▸  IoT</a:t>
+            </a:r>
+            <a:r>
+              <a:rPr sz="1450" b="0">
+                <a:solidFill>
+                  <a:srgbClr val="C9CED8"/>
+                </a:solidFill>
+                <a:latin typeface="Segoe UI"/>
+              </a:rPr>
+              <a:t> · sensör simülasyonu + MQTT + SQLite</a:t>
+            </a:r>
+          </a:p>
+          <a:p>
+            <a:pPr algn="l">
+              <a:spcBef>
+                <a:spcPts val="0"/>
+              </a:spcBef>
+              <a:spcAft>
+                <a:spcPts val="600"/>
+              </a:spcAft>
+            </a:pPr>
             <a:r>
               <a:rPr sz="1450" b="1">
                 <a:solidFill>
-                  <a:srgbClr val="62C8A8"/>
-                </a:solidFill>
-                <a:latin typeface="Segoe UI"/>
-              </a:rPr>
-              <a:t>IoT</a:t>
+                  <a:srgbClr val="6CD08A"/>
+                </a:solidFill>
+                <a:latin typeface="Segoe UI"/>
+              </a:rPr>
+              <a:t>▸  Algoritma</a:t>
             </a:r>
             <a:r>
               <a:rPr sz="1450" b="0">
@@ -5458,7 +5805,7 @@
                 </a:solidFill>
                 <a:latin typeface="Segoe UI"/>
               </a:rPr>
-              <a:t> · sensör simülasyonu + MQTT + SQLite</a:t>
+              <a:t> · graf + A* + maliyet fonk. + Hungarian</a:t>
             </a:r>
           </a:p>
           <a:p>
@@ -5473,57 +5820,11 @@
             <a:r>
               <a:rPr sz="1450" b="1">
                 <a:solidFill>
-                  <a:srgbClr val="6CD08A"/>
-                </a:solidFill>
-                <a:latin typeface="Segoe UI"/>
-              </a:rPr>
-              <a:t>▸  </a:t>
-            </a:r>
-            <a:r>
-              <a:rPr sz="1450" b="1">
-                <a:solidFill>
-                  <a:srgbClr val="6CD08A"/>
-                </a:solidFill>
-                <a:latin typeface="Segoe UI"/>
-              </a:rPr>
-              <a:t>Algoritma</a:t>
-            </a:r>
-            <a:r>
-              <a:rPr sz="1450" b="0">
-                <a:solidFill>
-                  <a:srgbClr val="C9CED8"/>
-                </a:solidFill>
-                <a:latin typeface="Segoe UI"/>
-              </a:rPr>
-              <a:t> · graf + A* + maliyet fonk. + Hungarian</a:t>
-            </a:r>
-          </a:p>
-          <a:p>
-            <a:pPr algn="l">
-              <a:spcBef>
-                <a:spcPts val="0"/>
-              </a:spcBef>
-              <a:spcAft>
-                <a:spcPts val="600"/>
-              </a:spcAft>
-            </a:pPr>
-            <a:r>
-              <a:rPr sz="1450" b="1">
-                <a:solidFill>
                   <a:srgbClr val="6CB8EE"/>
                 </a:solidFill>
                 <a:latin typeface="Segoe UI"/>
               </a:rPr>
-              <a:t>▸  </a:t>
-            </a:r>
-            <a:r>
-              <a:rPr sz="1450" b="1">
-                <a:solidFill>
-                  <a:srgbClr val="6CB8EE"/>
-                </a:solidFill>
-                <a:latin typeface="Segoe UI"/>
-              </a:rPr>
-              <a:t>LLM</a:t>
+              <a:t>▸  LLM</a:t>
             </a:r>
             <a:r>
               <a:rPr sz="1450" b="0">
@@ -5578,6 +5879,7 @@
           <a:lstStyle/>
           <a:p>
             <a:pPr algn="ctr"/>
+            <a:endParaRPr/>
           </a:p>
         </p:txBody>
       </p:sp>
@@ -5622,7 +5924,7 @@
           <a:noFill/>
         </p:spPr>
         <p:txBody>
-          <a:bodyPr wrap="square" anchor="t" lIns="0" rIns="0" tIns="0" bIns="0">
+          <a:bodyPr wrap="square" lIns="0" tIns="0" rIns="0" bIns="0" anchor="t">
             <a:spAutoFit/>
           </a:bodyPr>
           <a:lstStyle/>
@@ -5656,7 +5958,7 @@
 </file>
 
 <file path=ppt/slides/slide4.xml><?xml version="1.0" encoding="utf-8"?>
-<p:sld xmlns:a="http://schemas.openxmlformats.org/drawingml/2006/main" xmlns:p="http://schemas.openxmlformats.org/presentationml/2006/main" xmlns:r="http://schemas.openxmlformats.org/officeDocument/2006/relationships">
+<p:sld xmlns:a="http://schemas.openxmlformats.org/drawingml/2006/main" xmlns:r="http://schemas.openxmlformats.org/officeDocument/2006/relationships" xmlns:p="http://schemas.openxmlformats.org/presentationml/2006/main">
   <p:cSld>
     <p:spTree>
       <p:nvGrpSpPr>
@@ -5664,7 +5966,14 @@
         <p:cNvGrpSpPr/>
         <p:nvPr/>
       </p:nvGrpSpPr>
-      <p:grpSpPr/>
+      <p:grpSpPr>
+        <a:xfrm>
+          <a:off x="0" y="0"/>
+          <a:ext cx="0" cy="0"/>
+          <a:chOff x="0" y="0"/>
+          <a:chExt cx="0" cy="0"/>
+        </a:xfrm>
+      </p:grpSpPr>
       <p:sp>
         <p:nvSpPr>
           <p:cNvPr id="2" name="Rectangle 1"/>
@@ -5706,6 +6015,7 @@
           <a:lstStyle/>
           <a:p>
             <a:pPr algn="ctr"/>
+            <a:endParaRPr/>
           </a:p>
         </p:txBody>
       </p:sp>
@@ -5750,6 +6060,7 @@
           <a:lstStyle/>
           <a:p>
             <a:pPr algn="ctr"/>
+            <a:endParaRPr/>
           </a:p>
         </p:txBody>
       </p:sp>
@@ -5770,7 +6081,7 @@
           <a:noFill/>
         </p:spPr>
         <p:txBody>
-          <a:bodyPr wrap="square" anchor="t" lIns="0" rIns="0" tIns="0" bIns="0">
+          <a:bodyPr wrap="square" lIns="0" tIns="0" rIns="0" bIns="0" anchor="t">
             <a:spAutoFit/>
           </a:bodyPr>
           <a:lstStyle/>
@@ -5855,6 +6166,7 @@
           <a:lstStyle/>
           <a:p>
             <a:pPr algn="ctr"/>
+            <a:endParaRPr/>
           </a:p>
         </p:txBody>
       </p:sp>
@@ -5875,7 +6187,7 @@
           <a:noFill/>
         </p:spPr>
         <p:txBody>
-          <a:bodyPr wrap="square" anchor="t" lIns="0" rIns="0" tIns="0" bIns="0">
+          <a:bodyPr wrap="square" lIns="0" tIns="0" rIns="0" bIns="0" anchor="t">
             <a:spAutoFit/>
           </a:bodyPr>
           <a:lstStyle/>
@@ -5917,7 +6229,7 @@
           <a:noFill/>
         </p:spPr>
         <p:txBody>
-          <a:bodyPr wrap="square" anchor="t" lIns="0" rIns="0" tIns="0" bIns="0">
+          <a:bodyPr wrap="square" lIns="0" tIns="0" rIns="0" bIns="0" anchor="t">
             <a:spAutoFit/>
           </a:bodyPr>
           <a:lstStyle/>
@@ -5985,6 +6297,7 @@
           <a:lstStyle/>
           <a:p>
             <a:pPr algn="ctr"/>
+            <a:endParaRPr/>
           </a:p>
         </p:txBody>
       </p:sp>
@@ -6005,7 +6318,7 @@
           <a:noFill/>
         </p:spPr>
         <p:txBody>
-          <a:bodyPr wrap="square" anchor="ctr" lIns="0" rIns="0" tIns="0" bIns="0">
+          <a:bodyPr wrap="square" lIns="0" tIns="0" rIns="0" bIns="0" anchor="ctr">
             <a:spAutoFit/>
           </a:bodyPr>
           <a:lstStyle/>
@@ -6091,6 +6404,7 @@
           <a:lstStyle/>
           <a:p>
             <a:pPr algn="ctr"/>
+            <a:endParaRPr/>
           </a:p>
         </p:txBody>
       </p:sp>
@@ -6111,7 +6425,7 @@
           <a:noFill/>
         </p:spPr>
         <p:txBody>
-          <a:bodyPr wrap="square" anchor="t" lIns="0" rIns="0" tIns="0" bIns="0">
+          <a:bodyPr wrap="square" lIns="0" tIns="0" rIns="0" bIns="0" anchor="t">
             <a:spAutoFit/>
           </a:bodyPr>
           <a:lstStyle/>
@@ -6179,6 +6493,7 @@
           <a:lstStyle/>
           <a:p>
             <a:pPr algn="ctr"/>
+            <a:endParaRPr/>
           </a:p>
         </p:txBody>
       </p:sp>
@@ -6199,7 +6514,7 @@
           <a:noFill/>
         </p:spPr>
         <p:txBody>
-          <a:bodyPr wrap="square" anchor="ctr" lIns="0" rIns="0" tIns="0" bIns="0">
+          <a:bodyPr wrap="square" lIns="0" tIns="0" rIns="0" bIns="0" anchor="ctr">
             <a:spAutoFit/>
           </a:bodyPr>
           <a:lstStyle/>
@@ -6285,6 +6600,7 @@
           <a:lstStyle/>
           <a:p>
             <a:pPr algn="ctr"/>
+            <a:endParaRPr/>
           </a:p>
         </p:txBody>
       </p:sp>
@@ -6305,7 +6621,7 @@
           <a:noFill/>
         </p:spPr>
         <p:txBody>
-          <a:bodyPr wrap="square" anchor="t" lIns="0" rIns="0" tIns="0" bIns="0">
+          <a:bodyPr wrap="square" lIns="0" tIns="0" rIns="0" bIns="0" anchor="t">
             <a:spAutoFit/>
           </a:bodyPr>
           <a:lstStyle/>
@@ -6373,6 +6689,7 @@
           <a:lstStyle/>
           <a:p>
             <a:pPr algn="ctr"/>
+            <a:endParaRPr/>
           </a:p>
         </p:txBody>
       </p:sp>
@@ -6393,7 +6710,7 @@
           <a:noFill/>
         </p:spPr>
         <p:txBody>
-          <a:bodyPr wrap="square" anchor="ctr" lIns="0" rIns="0" tIns="0" bIns="0">
+          <a:bodyPr wrap="square" lIns="0" tIns="0" rIns="0" bIns="0" anchor="ctr">
             <a:spAutoFit/>
           </a:bodyPr>
           <a:lstStyle/>
@@ -6455,7 +6772,7 @@
           <a:noFill/>
         </p:spPr>
         <p:txBody>
-          <a:bodyPr wrap="square" anchor="t" lIns="0" rIns="0" tIns="0" bIns="0">
+          <a:bodyPr wrap="square" lIns="0" tIns="0" rIns="0" bIns="0" anchor="t">
             <a:spAutoFit/>
           </a:bodyPr>
           <a:lstStyle/>
@@ -6599,7 +6916,7 @@
 </file>
 
 <file path=ppt/slides/slide5.xml><?xml version="1.0" encoding="utf-8"?>
-<p:sld xmlns:a="http://schemas.openxmlformats.org/drawingml/2006/main" xmlns:p="http://schemas.openxmlformats.org/presentationml/2006/main" xmlns:r="http://schemas.openxmlformats.org/officeDocument/2006/relationships">
+<p:sld xmlns:a="http://schemas.openxmlformats.org/drawingml/2006/main" xmlns:r="http://schemas.openxmlformats.org/officeDocument/2006/relationships" xmlns:p="http://schemas.openxmlformats.org/presentationml/2006/main">
   <p:cSld>
     <p:spTree>
       <p:nvGrpSpPr>
@@ -6607,7 +6924,14 @@
         <p:cNvGrpSpPr/>
         <p:nvPr/>
       </p:nvGrpSpPr>
-      <p:grpSpPr/>
+      <p:grpSpPr>
+        <a:xfrm>
+          <a:off x="0" y="0"/>
+          <a:ext cx="0" cy="0"/>
+          <a:chOff x="0" y="0"/>
+          <a:chExt cx="0" cy="0"/>
+        </a:xfrm>
+      </p:grpSpPr>
       <p:sp>
         <p:nvSpPr>
           <p:cNvPr id="2" name="Rectangle 1"/>
@@ -6649,6 +6973,7 @@
           <a:lstStyle/>
           <a:p>
             <a:pPr algn="ctr"/>
+            <a:endParaRPr/>
           </a:p>
         </p:txBody>
       </p:sp>
@@ -6693,6 +7018,7 @@
           <a:lstStyle/>
           <a:p>
             <a:pPr algn="ctr"/>
+            <a:endParaRPr/>
           </a:p>
         </p:txBody>
       </p:sp>
@@ -6713,7 +7039,7 @@
           <a:noFill/>
         </p:spPr>
         <p:txBody>
-          <a:bodyPr wrap="square" anchor="t" lIns="0" rIns="0" tIns="0" bIns="0">
+          <a:bodyPr wrap="square" lIns="0" tIns="0" rIns="0" bIns="0" anchor="t">
             <a:spAutoFit/>
           </a:bodyPr>
           <a:lstStyle/>
@@ -6798,6 +7124,7 @@
           <a:lstStyle/>
           <a:p>
             <a:pPr algn="ctr"/>
+            <a:endParaRPr/>
           </a:p>
         </p:txBody>
       </p:sp>
@@ -6818,7 +7145,7 @@
           <a:noFill/>
         </p:spPr>
         <p:txBody>
-          <a:bodyPr wrap="square" anchor="t" lIns="0" rIns="0" tIns="0" bIns="0">
+          <a:bodyPr wrap="square" lIns="0" tIns="0" rIns="0" bIns="0" anchor="t">
             <a:spAutoFit/>
           </a:bodyPr>
           <a:lstStyle/>
@@ -6860,7 +7187,7 @@
           <a:noFill/>
         </p:spPr>
         <p:txBody>
-          <a:bodyPr wrap="square" anchor="t" lIns="0" rIns="0" tIns="0" bIns="0">
+          <a:bodyPr wrap="square" lIns="0" tIns="0" rIns="0" bIns="0" anchor="t">
             <a:spAutoFit/>
           </a:bodyPr>
           <a:lstStyle/>
@@ -6926,6 +7253,7 @@
           <a:lstStyle/>
           <a:p>
             <a:pPr algn="ctr"/>
+            <a:endParaRPr/>
           </a:p>
         </p:txBody>
       </p:sp>
@@ -6970,6 +7298,7 @@
           <a:lstStyle/>
           <a:p>
             <a:pPr algn="ctr"/>
+            <a:endParaRPr/>
           </a:p>
         </p:txBody>
       </p:sp>
@@ -6990,7 +7319,7 @@
           <a:noFill/>
         </p:spPr>
         <p:txBody>
-          <a:bodyPr wrap="square" anchor="t" lIns="0" rIns="0" tIns="0" bIns="0">
+          <a:bodyPr wrap="square" lIns="0" tIns="0" rIns="0" bIns="0" anchor="t">
             <a:spAutoFit/>
           </a:bodyPr>
           <a:lstStyle/>
@@ -7122,6 +7451,7 @@
           <a:lstStyle/>
           <a:p>
             <a:pPr algn="ctr"/>
+            <a:endParaRPr/>
           </a:p>
         </p:txBody>
       </p:sp>
@@ -7166,6 +7496,7 @@
           <a:lstStyle/>
           <a:p>
             <a:pPr algn="ctr"/>
+            <a:endParaRPr/>
           </a:p>
         </p:txBody>
       </p:sp>
@@ -7186,7 +7517,7 @@
           <a:noFill/>
         </p:spPr>
         <p:txBody>
-          <a:bodyPr wrap="square" anchor="t" lIns="0" rIns="0" tIns="0" bIns="0">
+          <a:bodyPr wrap="square" lIns="0" tIns="0" rIns="0" bIns="0" anchor="t">
             <a:spAutoFit/>
           </a:bodyPr>
           <a:lstStyle/>
@@ -7318,6 +7649,7 @@
           <a:lstStyle/>
           <a:p>
             <a:pPr algn="ctr"/>
+            <a:endParaRPr/>
           </a:p>
         </p:txBody>
       </p:sp>
@@ -7362,6 +7694,7 @@
           <a:lstStyle/>
           <a:p>
             <a:pPr algn="ctr"/>
+            <a:endParaRPr/>
           </a:p>
         </p:txBody>
       </p:sp>
@@ -7382,7 +7715,7 @@
           <a:noFill/>
         </p:spPr>
         <p:txBody>
-          <a:bodyPr wrap="square" anchor="t" lIns="0" rIns="0" tIns="0" bIns="0">
+          <a:bodyPr wrap="square" lIns="0" tIns="0" rIns="0" bIns="0" anchor="t">
             <a:spAutoFit/>
           </a:bodyPr>
           <a:lstStyle/>
@@ -7514,6 +7847,7 @@
           <a:lstStyle/>
           <a:p>
             <a:pPr algn="ctr"/>
+            <a:endParaRPr/>
           </a:p>
         </p:txBody>
       </p:sp>
@@ -7558,6 +7892,7 @@
           <a:lstStyle/>
           <a:p>
             <a:pPr algn="ctr"/>
+            <a:endParaRPr/>
           </a:p>
         </p:txBody>
       </p:sp>
@@ -7578,7 +7913,7 @@
           <a:noFill/>
         </p:spPr>
         <p:txBody>
-          <a:bodyPr wrap="square" anchor="t" lIns="0" rIns="0" tIns="0" bIns="0">
+          <a:bodyPr wrap="square" lIns="0" tIns="0" rIns="0" bIns="0" anchor="t">
             <a:spAutoFit/>
           </a:bodyPr>
           <a:lstStyle/>
@@ -7678,7 +8013,7 @@
 </file>
 
 <file path=ppt/slides/slide6.xml><?xml version="1.0" encoding="utf-8"?>
-<p:sld xmlns:a="http://schemas.openxmlformats.org/drawingml/2006/main" xmlns:p="http://schemas.openxmlformats.org/presentationml/2006/main" xmlns:r="http://schemas.openxmlformats.org/officeDocument/2006/relationships">
+<p:sld xmlns:a="http://schemas.openxmlformats.org/drawingml/2006/main" xmlns:r="http://schemas.openxmlformats.org/officeDocument/2006/relationships" xmlns:p="http://schemas.openxmlformats.org/presentationml/2006/main">
   <p:cSld>
     <p:spTree>
       <p:nvGrpSpPr>
@@ -7686,7 +8021,14 @@
         <p:cNvGrpSpPr/>
         <p:nvPr/>
       </p:nvGrpSpPr>
-      <p:grpSpPr/>
+      <p:grpSpPr>
+        <a:xfrm>
+          <a:off x="0" y="0"/>
+          <a:ext cx="0" cy="0"/>
+          <a:chOff x="0" y="0"/>
+          <a:chExt cx="0" cy="0"/>
+        </a:xfrm>
+      </p:grpSpPr>
       <p:sp>
         <p:nvSpPr>
           <p:cNvPr id="2" name="Rectangle 1"/>
@@ -7728,6 +8070,7 @@
           <a:lstStyle/>
           <a:p>
             <a:pPr algn="ctr"/>
+            <a:endParaRPr/>
           </a:p>
         </p:txBody>
       </p:sp>
@@ -7772,6 +8115,7 @@
           <a:lstStyle/>
           <a:p>
             <a:pPr algn="ctr"/>
+            <a:endParaRPr/>
           </a:p>
         </p:txBody>
       </p:sp>
@@ -7792,7 +8136,7 @@
           <a:noFill/>
         </p:spPr>
         <p:txBody>
-          <a:bodyPr wrap="square" anchor="t" lIns="0" rIns="0" tIns="0" bIns="0">
+          <a:bodyPr wrap="square" lIns="0" tIns="0" rIns="0" bIns="0" anchor="t">
             <a:spAutoFit/>
           </a:bodyPr>
           <a:lstStyle/>
@@ -7877,6 +8221,7 @@
           <a:lstStyle/>
           <a:p>
             <a:pPr algn="ctr"/>
+            <a:endParaRPr/>
           </a:p>
         </p:txBody>
       </p:sp>
@@ -7897,7 +8242,7 @@
           <a:noFill/>
         </p:spPr>
         <p:txBody>
-          <a:bodyPr wrap="square" anchor="t" lIns="0" rIns="0" tIns="0" bIns="0">
+          <a:bodyPr wrap="square" lIns="0" tIns="0" rIns="0" bIns="0" anchor="t">
             <a:spAutoFit/>
           </a:bodyPr>
           <a:lstStyle/>
@@ -7939,7 +8284,7 @@
           <a:noFill/>
         </p:spPr>
         <p:txBody>
-          <a:bodyPr wrap="square" anchor="t" lIns="0" rIns="0" tIns="0" bIns="0">
+          <a:bodyPr wrap="square" lIns="0" tIns="0" rIns="0" bIns="0" anchor="t">
             <a:spAutoFit/>
           </a:bodyPr>
           <a:lstStyle/>
@@ -7981,7 +8326,7 @@
           <a:noFill/>
         </p:spPr>
         <p:txBody>
-          <a:bodyPr wrap="square" anchor="t" lIns="0" rIns="0" tIns="0" bIns="0">
+          <a:bodyPr wrap="square" lIns="0" tIns="0" rIns="0" bIns="0" anchor="t">
             <a:spAutoFit/>
           </a:bodyPr>
           <a:lstStyle/>
@@ -8068,6 +8413,7 @@
           <a:lstStyle/>
           <a:p>
             <a:pPr algn="ctr"/>
+            <a:endParaRPr/>
           </a:p>
         </p:txBody>
       </p:sp>
@@ -8112,6 +8458,7 @@
           <a:lstStyle/>
           <a:p>
             <a:pPr algn="ctr"/>
+            <a:endParaRPr/>
           </a:p>
         </p:txBody>
       </p:sp>
@@ -8132,7 +8479,7 @@
           <a:noFill/>
         </p:spPr>
         <p:txBody>
-          <a:bodyPr wrap="square" anchor="t" lIns="0" rIns="0" tIns="0" bIns="0">
+          <a:bodyPr wrap="square" lIns="0" tIns="0" rIns="0" bIns="0" anchor="t">
             <a:spAutoFit/>
           </a:bodyPr>
           <a:lstStyle/>
@@ -8211,15 +8558,12 @@
                 <a:spcPts val="400"/>
               </a:spcAft>
             </a:pPr>
-            <a:r>
-              <a:rPr sz="1250" b="0">
-                <a:solidFill>
-                  <a:srgbClr val="C9CED8"/>
-                </a:solidFill>
-                <a:latin typeface="Segoe UI"/>
-              </a:rPr>
-              <a:t/>
-            </a:r>
+            <a:endParaRPr sz="1250" b="0">
+              <a:solidFill>
+                <a:srgbClr val="C9CED8"/>
+              </a:solidFill>
+              <a:latin typeface="Segoe UI"/>
+            </a:endParaRPr>
           </a:p>
           <a:p>
             <a:pPr algn="l">
@@ -8308,6 +8652,7 @@
           <a:lstStyle/>
           <a:p>
             <a:pPr algn="ctr"/>
+            <a:endParaRPr/>
           </a:p>
         </p:txBody>
       </p:sp>
@@ -8352,6 +8697,7 @@
           <a:lstStyle/>
           <a:p>
             <a:pPr algn="ctr"/>
+            <a:endParaRPr/>
           </a:p>
         </p:txBody>
       </p:sp>
@@ -8372,7 +8718,7 @@
           <a:noFill/>
         </p:spPr>
         <p:txBody>
-          <a:bodyPr wrap="square" anchor="t" lIns="0" rIns="0" tIns="0" bIns="0">
+          <a:bodyPr wrap="square" lIns="0" tIns="0" rIns="0" bIns="0" anchor="t">
             <a:spAutoFit/>
           </a:bodyPr>
           <a:lstStyle/>
@@ -8473,15 +8819,12 @@
                 <a:spcPts val="400"/>
               </a:spcAft>
             </a:pPr>
-            <a:r>
-              <a:rPr sz="1250" b="0">
-                <a:solidFill>
-                  <a:srgbClr val="C9CED8"/>
-                </a:solidFill>
-                <a:latin typeface="Segoe UI"/>
-              </a:rPr>
-              <a:t/>
-            </a:r>
+            <a:endParaRPr sz="1250" b="0">
+              <a:solidFill>
+                <a:srgbClr val="C9CED8"/>
+              </a:solidFill>
+              <a:latin typeface="Segoe UI"/>
+            </a:endParaRPr>
           </a:p>
           <a:p>
             <a:pPr algn="l">
@@ -8524,7 +8867,7 @@
           <a:noFill/>
         </p:spPr>
         <p:txBody>
-          <a:bodyPr wrap="square" anchor="t" lIns="0" rIns="0" tIns="0" bIns="0">
+          <a:bodyPr wrap="square" lIns="0" tIns="0" rIns="0" bIns="0" anchor="t">
             <a:spAutoFit/>
           </a:bodyPr>
           <a:lstStyle/>
@@ -8570,7 +8913,7 @@
 </file>
 
 <file path=ppt/slides/slide7.xml><?xml version="1.0" encoding="utf-8"?>
-<p:sld xmlns:a="http://schemas.openxmlformats.org/drawingml/2006/main" xmlns:p="http://schemas.openxmlformats.org/presentationml/2006/main" xmlns:r="http://schemas.openxmlformats.org/officeDocument/2006/relationships">
+<p:sld xmlns:a="http://schemas.openxmlformats.org/drawingml/2006/main" xmlns:r="http://schemas.openxmlformats.org/officeDocument/2006/relationships" xmlns:p="http://schemas.openxmlformats.org/presentationml/2006/main">
   <p:cSld>
     <p:spTree>
       <p:nvGrpSpPr>
@@ -8578,7 +8921,14 @@
         <p:cNvGrpSpPr/>
         <p:nvPr/>
       </p:nvGrpSpPr>
-      <p:grpSpPr/>
+      <p:grpSpPr>
+        <a:xfrm>
+          <a:off x="0" y="0"/>
+          <a:ext cx="0" cy="0"/>
+          <a:chOff x="0" y="0"/>
+          <a:chExt cx="0" cy="0"/>
+        </a:xfrm>
+      </p:grpSpPr>
       <p:sp>
         <p:nvSpPr>
           <p:cNvPr id="2" name="Rectangle 1"/>
@@ -8620,6 +8970,7 @@
           <a:lstStyle/>
           <a:p>
             <a:pPr algn="ctr"/>
+            <a:endParaRPr/>
           </a:p>
         </p:txBody>
       </p:sp>
@@ -8664,6 +9015,7 @@
           <a:lstStyle/>
           <a:p>
             <a:pPr algn="ctr"/>
+            <a:endParaRPr/>
           </a:p>
         </p:txBody>
       </p:sp>
@@ -8684,7 +9036,7 @@
           <a:noFill/>
         </p:spPr>
         <p:txBody>
-          <a:bodyPr wrap="square" anchor="t" lIns="0" rIns="0" tIns="0" bIns="0">
+          <a:bodyPr wrap="square" lIns="0" tIns="0" rIns="0" bIns="0" anchor="t">
             <a:spAutoFit/>
           </a:bodyPr>
           <a:lstStyle/>
@@ -8769,6 +9121,7 @@
           <a:lstStyle/>
           <a:p>
             <a:pPr algn="ctr"/>
+            <a:endParaRPr/>
           </a:p>
         </p:txBody>
       </p:sp>
@@ -8789,7 +9142,7 @@
           <a:noFill/>
         </p:spPr>
         <p:txBody>
-          <a:bodyPr wrap="square" anchor="t" lIns="0" rIns="0" tIns="0" bIns="0">
+          <a:bodyPr wrap="square" lIns="0" tIns="0" rIns="0" bIns="0" anchor="t">
             <a:spAutoFit/>
           </a:bodyPr>
           <a:lstStyle/>
@@ -8831,7 +9184,7 @@
           <a:noFill/>
         </p:spPr>
         <p:txBody>
-          <a:bodyPr wrap="square" anchor="t" lIns="0" rIns="0" tIns="0" bIns="0">
+          <a:bodyPr wrap="square" lIns="0" tIns="0" rIns="0" bIns="0" anchor="t">
             <a:spAutoFit/>
           </a:bodyPr>
           <a:lstStyle/>
@@ -8873,7 +9226,7 @@
           <a:noFill/>
         </p:spPr>
         <p:txBody>
-          <a:bodyPr wrap="square" anchor="t" lIns="0" rIns="0" tIns="0" bIns="0">
+          <a:bodyPr wrap="square" lIns="0" tIns="0" rIns="0" bIns="0" anchor="t">
             <a:spAutoFit/>
           </a:bodyPr>
           <a:lstStyle/>
@@ -9125,6 +9478,7 @@
           <a:lstStyle/>
           <a:p>
             <a:pPr algn="ctr"/>
+            <a:endParaRPr/>
           </a:p>
         </p:txBody>
       </p:sp>
@@ -9169,6 +9523,7 @@
           <a:lstStyle/>
           <a:p>
             <a:pPr algn="ctr"/>
+            <a:endParaRPr/>
           </a:p>
         </p:txBody>
       </p:sp>
@@ -9189,7 +9544,7 @@
           <a:noFill/>
         </p:spPr>
         <p:txBody>
-          <a:bodyPr wrap="square" anchor="t" lIns="0" rIns="0" tIns="0" bIns="0">
+          <a:bodyPr wrap="square" lIns="0" tIns="0" rIns="0" bIns="0" anchor="t">
             <a:spAutoFit/>
           </a:bodyPr>
           <a:lstStyle/>
@@ -9332,7 +9687,7 @@
           <a:noFill/>
         </p:spPr>
         <p:txBody>
-          <a:bodyPr wrap="square" anchor="t" lIns="0" rIns="0" tIns="0" bIns="0">
+          <a:bodyPr wrap="square" lIns="0" tIns="0" rIns="0" bIns="0" anchor="t">
             <a:spAutoFit/>
           </a:bodyPr>
           <a:lstStyle/>
@@ -9421,7 +9776,7 @@
 </file>
 
 <file path=ppt/slides/slide8.xml><?xml version="1.0" encoding="utf-8"?>
-<p:sld xmlns:a="http://schemas.openxmlformats.org/drawingml/2006/main" xmlns:p="http://schemas.openxmlformats.org/presentationml/2006/main" xmlns:r="http://schemas.openxmlformats.org/officeDocument/2006/relationships">
+<p:sld xmlns:a="http://schemas.openxmlformats.org/drawingml/2006/main" xmlns:r="http://schemas.openxmlformats.org/officeDocument/2006/relationships" xmlns:p="http://schemas.openxmlformats.org/presentationml/2006/main">
   <p:cSld>
     <p:spTree>
       <p:nvGrpSpPr>
@@ -9429,7 +9784,14 @@
         <p:cNvGrpSpPr/>
         <p:nvPr/>
       </p:nvGrpSpPr>
-      <p:grpSpPr/>
+      <p:grpSpPr>
+        <a:xfrm>
+          <a:off x="0" y="0"/>
+          <a:ext cx="0" cy="0"/>
+          <a:chOff x="0" y="0"/>
+          <a:chExt cx="0" cy="0"/>
+        </a:xfrm>
+      </p:grpSpPr>
       <p:sp>
         <p:nvSpPr>
           <p:cNvPr id="2" name="Rectangle 1"/>
@@ -9471,6 +9833,7 @@
           <a:lstStyle/>
           <a:p>
             <a:pPr algn="ctr"/>
+            <a:endParaRPr/>
           </a:p>
         </p:txBody>
       </p:sp>
@@ -9515,6 +9878,7 @@
           <a:lstStyle/>
           <a:p>
             <a:pPr algn="ctr"/>
+            <a:endParaRPr/>
           </a:p>
         </p:txBody>
       </p:sp>
@@ -9535,7 +9899,7 @@
           <a:noFill/>
         </p:spPr>
         <p:txBody>
-          <a:bodyPr wrap="square" anchor="t" lIns="0" rIns="0" tIns="0" bIns="0">
+          <a:bodyPr wrap="square" lIns="0" tIns="0" rIns="0" bIns="0" anchor="t">
             <a:spAutoFit/>
           </a:bodyPr>
           <a:lstStyle/>
@@ -9620,6 +9984,7 @@
           <a:lstStyle/>
           <a:p>
             <a:pPr algn="ctr"/>
+            <a:endParaRPr/>
           </a:p>
         </p:txBody>
       </p:sp>
@@ -9640,7 +10005,7 @@
           <a:noFill/>
         </p:spPr>
         <p:txBody>
-          <a:bodyPr wrap="square" anchor="t" lIns="0" rIns="0" tIns="0" bIns="0">
+          <a:bodyPr wrap="square" lIns="0" tIns="0" rIns="0" bIns="0" anchor="t">
             <a:spAutoFit/>
           </a:bodyPr>
           <a:lstStyle/>
@@ -9682,7 +10047,7 @@
           <a:noFill/>
         </p:spPr>
         <p:txBody>
-          <a:bodyPr wrap="square" anchor="t" lIns="0" rIns="0" tIns="0" bIns="0">
+          <a:bodyPr wrap="square" lIns="0" tIns="0" rIns="0" bIns="0" anchor="t">
             <a:spAutoFit/>
           </a:bodyPr>
           <a:lstStyle/>
@@ -9748,6 +10113,7 @@
           <a:lstStyle/>
           <a:p>
             <a:pPr algn="ctr"/>
+            <a:endParaRPr/>
           </a:p>
         </p:txBody>
       </p:sp>
@@ -9768,7 +10134,7 @@
           <a:noFill/>
         </p:spPr>
         <p:txBody>
-          <a:bodyPr wrap="square" anchor="ctr" lIns="0" rIns="0" tIns="0" bIns="0">
+          <a:bodyPr wrap="square" lIns="0" tIns="0" rIns="0" bIns="0" anchor="ctr">
             <a:spAutoFit/>
           </a:bodyPr>
           <a:lstStyle/>
@@ -9822,7 +10188,7 @@
           <a:noFill/>
         </p:spPr>
         <p:txBody>
-          <a:bodyPr wrap="square" anchor="t" lIns="0" rIns="0" tIns="0" bIns="0">
+          <a:bodyPr wrap="square" lIns="0" tIns="0" rIns="0" bIns="0" anchor="t">
             <a:spAutoFit/>
           </a:bodyPr>
           <a:lstStyle/>
@@ -10073,6 +10439,7 @@
           <a:lstStyle/>
           <a:p>
             <a:pPr algn="ctr"/>
+            <a:endParaRPr/>
           </a:p>
         </p:txBody>
       </p:sp>
@@ -10093,7 +10460,7 @@
           <a:noFill/>
         </p:spPr>
         <p:txBody>
-          <a:bodyPr wrap="square" anchor="t" lIns="0" rIns="0" tIns="0" bIns="0">
+          <a:bodyPr wrap="square" lIns="0" tIns="0" rIns="0" bIns="0" anchor="t">
             <a:spAutoFit/>
           </a:bodyPr>
           <a:lstStyle/>
@@ -10251,7 +10618,7 @@
 </file>
 
 <file path=ppt/slides/slide9.xml><?xml version="1.0" encoding="utf-8"?>
-<p:sld xmlns:a="http://schemas.openxmlformats.org/drawingml/2006/main" xmlns:p="http://schemas.openxmlformats.org/presentationml/2006/main" xmlns:r="http://schemas.openxmlformats.org/officeDocument/2006/relationships">
+<p:sld xmlns:a="http://schemas.openxmlformats.org/drawingml/2006/main" xmlns:r="http://schemas.openxmlformats.org/officeDocument/2006/relationships" xmlns:p="http://schemas.openxmlformats.org/presentationml/2006/main">
   <p:cSld>
     <p:spTree>
       <p:nvGrpSpPr>
@@ -10259,7 +10626,14 @@
         <p:cNvGrpSpPr/>
         <p:nvPr/>
       </p:nvGrpSpPr>
-      <p:grpSpPr/>
+      <p:grpSpPr>
+        <a:xfrm>
+          <a:off x="0" y="0"/>
+          <a:ext cx="0" cy="0"/>
+          <a:chOff x="0" y="0"/>
+          <a:chExt cx="0" cy="0"/>
+        </a:xfrm>
+      </p:grpSpPr>
       <p:sp>
         <p:nvSpPr>
           <p:cNvPr id="2" name="Rectangle 1"/>
@@ -10301,6 +10675,7 @@
           <a:lstStyle/>
           <a:p>
             <a:pPr algn="ctr"/>
+            <a:endParaRPr/>
           </a:p>
         </p:txBody>
       </p:sp>
@@ -10345,6 +10720,7 @@
           <a:lstStyle/>
           <a:p>
             <a:pPr algn="ctr"/>
+            <a:endParaRPr/>
           </a:p>
         </p:txBody>
       </p:sp>
@@ -10365,7 +10741,7 @@
           <a:noFill/>
         </p:spPr>
         <p:txBody>
-          <a:bodyPr wrap="square" anchor="t" lIns="0" rIns="0" tIns="0" bIns="0">
+          <a:bodyPr wrap="square" lIns="0" tIns="0" rIns="0" bIns="0" anchor="t">
             <a:spAutoFit/>
           </a:bodyPr>
           <a:lstStyle/>
@@ -10450,6 +10826,7 @@
           <a:lstStyle/>
           <a:p>
             <a:pPr algn="ctr"/>
+            <a:endParaRPr/>
           </a:p>
         </p:txBody>
       </p:sp>
@@ -10470,7 +10847,7 @@
           <a:noFill/>
         </p:spPr>
         <p:txBody>
-          <a:bodyPr wrap="square" anchor="t" lIns="0" rIns="0" tIns="0" bIns="0">
+          <a:bodyPr wrap="square" lIns="0" tIns="0" rIns="0" bIns="0" anchor="t">
             <a:spAutoFit/>
           </a:bodyPr>
           <a:lstStyle/>
@@ -10512,7 +10889,7 @@
           <a:noFill/>
         </p:spPr>
         <p:txBody>
-          <a:bodyPr wrap="square" anchor="t" lIns="0" rIns="0" tIns="0" bIns="0">
+          <a:bodyPr wrap="square" lIns="0" tIns="0" rIns="0" bIns="0" anchor="t">
             <a:spAutoFit/>
           </a:bodyPr>
           <a:lstStyle/>
@@ -10578,6 +10955,7 @@
           <a:lstStyle/>
           <a:p>
             <a:pPr algn="ctr"/>
+            <a:endParaRPr/>
           </a:p>
         </p:txBody>
       </p:sp>
@@ -10622,6 +11000,7 @@
           <a:lstStyle/>
           <a:p>
             <a:pPr algn="ctr"/>
+            <a:endParaRPr/>
           </a:p>
         </p:txBody>
       </p:sp>
@@ -10642,7 +11021,7 @@
           <a:noFill/>
         </p:spPr>
         <p:txBody>
-          <a:bodyPr wrap="square" anchor="ctr" lIns="0" rIns="0" tIns="0" bIns="0">
+          <a:bodyPr wrap="square" lIns="0" tIns="0" rIns="0" bIns="0" anchor="ctr">
             <a:spAutoFit/>
           </a:bodyPr>
           <a:lstStyle/>
@@ -10720,6 +11099,7 @@
           <a:lstStyle/>
           <a:p>
             <a:pPr algn="ctr"/>
+            <a:endParaRPr/>
           </a:p>
         </p:txBody>
       </p:sp>
@@ -10764,6 +11144,7 @@
           <a:lstStyle/>
           <a:p>
             <a:pPr algn="ctr"/>
+            <a:endParaRPr/>
           </a:p>
         </p:txBody>
       </p:sp>
@@ -10784,7 +11165,7 @@
           <a:noFill/>
         </p:spPr>
         <p:txBody>
-          <a:bodyPr wrap="square" anchor="ctr" lIns="0" rIns="0" tIns="0" bIns="0">
+          <a:bodyPr wrap="square" lIns="0" tIns="0" rIns="0" bIns="0" anchor="ctr">
             <a:spAutoFit/>
           </a:bodyPr>
           <a:lstStyle/>
@@ -10862,6 +11243,7 @@
           <a:lstStyle/>
           <a:p>
             <a:pPr algn="ctr"/>
+            <a:endParaRPr/>
           </a:p>
         </p:txBody>
       </p:sp>
@@ -10906,6 +11288,7 @@
           <a:lstStyle/>
           <a:p>
             <a:pPr algn="ctr"/>
+            <a:endParaRPr/>
           </a:p>
         </p:txBody>
       </p:sp>
@@ -10926,7 +11309,7 @@
           <a:noFill/>
         </p:spPr>
         <p:txBody>
-          <a:bodyPr wrap="square" anchor="ctr" lIns="0" rIns="0" tIns="0" bIns="0">
+          <a:bodyPr wrap="square" lIns="0" tIns="0" rIns="0" bIns="0" anchor="ctr">
             <a:spAutoFit/>
           </a:bodyPr>
           <a:lstStyle/>
@@ -11004,6 +11387,7 @@
           <a:lstStyle/>
           <a:p>
             <a:pPr algn="ctr"/>
+            <a:endParaRPr/>
           </a:p>
         </p:txBody>
       </p:sp>
@@ -11048,6 +11432,7 @@
           <a:lstStyle/>
           <a:p>
             <a:pPr algn="ctr"/>
+            <a:endParaRPr/>
           </a:p>
         </p:txBody>
       </p:sp>
@@ -11068,7 +11453,7 @@
           <a:noFill/>
         </p:spPr>
         <p:txBody>
-          <a:bodyPr wrap="square" anchor="ctr" lIns="0" rIns="0" tIns="0" bIns="0">
+          <a:bodyPr wrap="square" lIns="0" tIns="0" rIns="0" bIns="0" anchor="ctr">
             <a:spAutoFit/>
           </a:bodyPr>
           <a:lstStyle/>
@@ -11146,6 +11531,7 @@
           <a:lstStyle/>
           <a:p>
             <a:pPr algn="ctr"/>
+            <a:endParaRPr/>
           </a:p>
         </p:txBody>
       </p:sp>
@@ -11190,6 +11576,7 @@
           <a:lstStyle/>
           <a:p>
             <a:pPr algn="ctr"/>
+            <a:endParaRPr/>
           </a:p>
         </p:txBody>
       </p:sp>
@@ -11210,7 +11597,7 @@
           <a:noFill/>
         </p:spPr>
         <p:txBody>
-          <a:bodyPr wrap="square" anchor="ctr" lIns="0" rIns="0" tIns="0" bIns="0">
+          <a:bodyPr wrap="square" lIns="0" tIns="0" rIns="0" bIns="0" anchor="ctr">
             <a:spAutoFit/>
           </a:bodyPr>
           <a:lstStyle/>
@@ -11288,6 +11675,7 @@
           <a:lstStyle/>
           <a:p>
             <a:pPr algn="ctr"/>
+            <a:endParaRPr/>
           </a:p>
         </p:txBody>
       </p:sp>
@@ -11332,6 +11720,7 @@
           <a:lstStyle/>
           <a:p>
             <a:pPr algn="ctr"/>
+            <a:endParaRPr/>
           </a:p>
         </p:txBody>
       </p:sp>
@@ -11352,7 +11741,7 @@
           <a:noFill/>
         </p:spPr>
         <p:txBody>
-          <a:bodyPr wrap="square" anchor="ctr" lIns="0" rIns="0" tIns="0" bIns="0">
+          <a:bodyPr wrap="square" lIns="0" tIns="0" rIns="0" bIns="0" anchor="ctr">
             <a:spAutoFit/>
           </a:bodyPr>
           <a:lstStyle/>
@@ -11430,6 +11819,7 @@
           <a:lstStyle/>
           <a:p>
             <a:pPr algn="ctr"/>
+            <a:endParaRPr/>
           </a:p>
         </p:txBody>
       </p:sp>
@@ -11474,7 +11864,7 @@
           <a:noFill/>
         </p:spPr>
         <p:txBody>
-          <a:bodyPr wrap="square" anchor="t" lIns="0" rIns="0" tIns="0" bIns="0">
+          <a:bodyPr wrap="square" lIns="0" tIns="0" rIns="0" bIns="0" anchor="t">
             <a:spAutoFit/>
           </a:bodyPr>
           <a:lstStyle/>
@@ -11516,7 +11906,7 @@
           <a:noFill/>
         </p:spPr>
         <p:txBody>
-          <a:bodyPr wrap="square" anchor="t" lIns="0" rIns="0" tIns="0" bIns="0">
+          <a:bodyPr wrap="square" lIns="0" tIns="0" rIns="0" bIns="0" anchor="t">
             <a:spAutoFit/>
           </a:bodyPr>
           <a:lstStyle/>

</xml_diff>